<commit_message>
Sync executive deck with Korean FX/tax reframing (18 slides)
Slide 10 band now frames the individual-first idea as a legitimate
Korean FX/tax-driven arrangement that must land pro rata; new slide 11
'Korean FX/tax - choosing the compliant path' compares direct swap,
holdco block entry (recommended) and the documented individual-first
bridge, with a counsel-confirmation note.

Co-Authored-By: Claude Fable 5 <noreply@anthropic.com>
Claude-Session: https://claude.ai/code/session_01AQEsBRx3YjneicK8t6qK39
</commit_message>
<xml_diff>
--- a/synexo/GenApep_Executive_Presentation.pptx
+++ b/synexo/GenApep_Executive_Presentation.pptx
@@ -22,6 +22,7 @@
     <p:sldId id="270" r:id="rId21"/>
     <p:sldId id="271" r:id="rId22"/>
     <p:sldId id="272" r:id="rId23"/>
+    <p:sldId id="273" r:id="rId24"/>
   </p:sldIdLst>
   <p:sldSz cx="12191695" cy="6858000" type="screen4x3"/>
   <p:notesSz cx="6858000" cy="9144000"/>
@@ -4520,7 +4521,7 @@
                 </a:solidFill>
                 <a:latin typeface="Calibri"/>
               </a:rPr>
-              <a:t>The fix is sequencing, not abandonment.</a:t>
+              <a:t>The fix is documentation and sequencing — not abandonment.</a:t>
             </a:r>
           </a:p>
           <a:p>
@@ -4532,7 +4533,7 @@
                 </a:solidFill>
                 <a:latin typeface="Calibri"/>
               </a:rPr>
-              <a:t>Form the Joint Venture first, then approach First Vital as one block with one agreed internal split. Same commercial outcome, none of the governance defects — and zero calendar cost, because the audit runs on the critical path either way.</a:t>
+              <a:t>The individual-first idea has a legitimate driver — Korean FX filings and dry tax charges on a direct swap (next slide). It must simply land pro rata: through the holdco block, or a documented nominee bridge. Same commercial outcome, none of the defects — and zero calendar cost, because the audit is the critical path either way.</a:t>
             </a:r>
           </a:p>
         </p:txBody>
@@ -4677,7 +4678,7 @@
                 </a:solidFill>
                 <a:latin typeface="Calibri"/>
               </a:rPr>
-              <a:t>Recommended shareholding structure</a:t>
+              <a:t>Korean FX/tax — choosing the compliant path</a:t>
             </a:r>
           </a:p>
         </p:txBody>
@@ -4716,7 +4717,7 @@
                 </a:solidFill>
                 <a:latin typeface="Calibri"/>
               </a:rPr>
-              <a:t>FVH's structure is undetermined — set it by value, enter as one block</a:t>
+              <a:t>Why “individuals first” was proposed, and how to keep its benefit safely</a:t>
             </a:r>
           </a:p>
         </p:txBody>
@@ -4756,6 +4757,651 @@
                 <a:latin typeface="Calibri"/>
               </a:rPr>
               <a:t>11</a:t>
+            </a:r>
+          </a:p>
+        </p:txBody>
+      </p:sp>
+      <p:sp>
+        <p:nvSpPr>
+          <p:cNvPr id="7" name="Rounded Rectangle 6"/>
+          <p:cNvSpPr/>
+          <p:nvPr/>
+        </p:nvSpPr>
+        <p:spPr>
+          <a:xfrm>
+            <a:off x="640080" y="1417320"/>
+            <a:ext cx="10927080" cy="1234440"/>
+          </a:xfrm>
+          <a:prstGeom prst="roundRect">
+            <a:avLst/>
+          </a:prstGeom>
+          <a:solidFill>
+            <a:srgbClr val="FFFFFF"/>
+          </a:solidFill>
+          <a:ln w="19050">
+            <a:solidFill>
+              <a:srgbClr val="2E86C1"/>
+            </a:solidFill>
+          </a:ln>
+        </p:spPr>
+        <p:style>
+          <a:lnRef idx="1">
+            <a:schemeClr val="accent1"/>
+          </a:lnRef>
+          <a:fillRef idx="3">
+            <a:schemeClr val="accent1"/>
+          </a:fillRef>
+          <a:effectRef idx="2">
+            <a:schemeClr val="accent1"/>
+          </a:effectRef>
+          <a:fontRef idx="minor">
+            <a:schemeClr val="lt1"/>
+          </a:fontRef>
+        </p:style>
+        <p:txBody>
+          <a:bodyPr rtlCol="0" anchor="t" wrap="square" lIns="127000" rIns="127000" tIns="101600"/>
+          <a:lstStyle/>
+          <a:p>
+            <a:pPr algn="l"/>
+            <a:r>
+              <a:rPr sz="1600" b="1">
+                <a:solidFill>
+                  <a:srgbClr val="1B3355"/>
+                </a:solidFill>
+                <a:latin typeface="Calibri"/>
+              </a:rPr>
+              <a:t>The burden being avoided is real</a:t>
+            </a:r>
+          </a:p>
+          <a:p>
+            <a:pPr algn="l">
+              <a:spcBef>
+                <a:spcPts val="400"/>
+              </a:spcBef>
+            </a:pPr>
+            <a:r>
+              <a:rPr sz="1350">
+                <a:solidFill>
+                  <a:srgbClr val="5A5A5A"/>
+                </a:solidFill>
+                <a:latin typeface="Calibri"/>
+              </a:rPr>
+              <a:t>Every Korean shareholder must make foreign-exchange filings for foreign securities, and a share-for-share exchange is generally a TAXABLE DISPOSAL — tax due in cash while the consideration arrives as shares, with no rollover into a foreign parent. Dozens of individual filings and dry tax charges could stall the transaction.</a:t>
+            </a:r>
+          </a:p>
+        </p:txBody>
+      </p:sp>
+      <p:graphicFrame>
+        <p:nvGraphicFramePr>
+          <p:cNvPr id="8" name="Table 7"/>
+          <p:cNvGraphicFramePr>
+            <a:graphicFrameLocks noGrp="1"/>
+          </p:cNvGraphicFramePr>
+          <p:nvPr/>
+        </p:nvGraphicFramePr>
+        <p:xfrm>
+          <a:off x="640080" y="2834640"/>
+          <a:ext cx="10927080" cy="1463040"/>
+        </p:xfrm>
+        <a:graphic>
+          <a:graphicData uri="http://schemas.openxmlformats.org/drawingml/2006/table">
+            <a:tbl>
+              <a:tblPr firstRow="1" bandRow="1">
+                <a:tableStyleId>{5C22544A-7EE6-4342-B048-85BDC9FD1C3A}</a:tableStyleId>
+              </a:tblPr>
+              <a:tblGrid>
+                <a:gridCol w="2240280"/>
+                <a:gridCol w="4892040"/>
+                <a:gridCol w="3794760"/>
+              </a:tblGrid>
+              <a:tr h="365760">
+                <a:tc>
+                  <a:txBody>
+                    <a:bodyPr/>
+                    <a:lstStyle/>
+                    <a:p>
+                      <a:pPr algn="l"/>
+                      <a:r>
+                        <a:rPr sz="1250" b="1">
+                          <a:solidFill>
+                            <a:srgbClr val="FFFFFF"/>
+                          </a:solidFill>
+                        </a:rPr>
+                        <a:t>Path</a:t>
+                      </a:r>
+                    </a:p>
+                  </a:txBody>
+                  <a:tcPr>
+                    <a:solidFill>
+                      <a:srgbClr val="1B3355"/>
+                    </a:solidFill>
+                  </a:tcPr>
+                </a:tc>
+                <a:tc>
+                  <a:txBody>
+                    <a:bodyPr/>
+                    <a:lstStyle/>
+                    <a:p>
+                      <a:pPr algn="ctr"/>
+                      <a:r>
+                        <a:rPr sz="1250" b="1">
+                          <a:solidFill>
+                            <a:srgbClr val="FFFFFF"/>
+                          </a:solidFill>
+                        </a:rPr>
+                        <a:t>Mechanics</a:t>
+                      </a:r>
+                    </a:p>
+                  </a:txBody>
+                  <a:tcPr>
+                    <a:solidFill>
+                      <a:srgbClr val="1B3355"/>
+                    </a:solidFill>
+                  </a:tcPr>
+                </a:tc>
+                <a:tc>
+                  <a:txBody>
+                    <a:bodyPr/>
+                    <a:lstStyle/>
+                    <a:p>
+                      <a:pPr algn="ctr"/>
+                      <a:r>
+                        <a:rPr sz="1250" b="1">
+                          <a:solidFill>
+                            <a:srgbClr val="FFFFFF"/>
+                          </a:solidFill>
+                        </a:rPr>
+                        <a:t>Assessment</a:t>
+                      </a:r>
+                    </a:p>
+                  </a:txBody>
+                  <a:tcPr>
+                    <a:solidFill>
+                      <a:srgbClr val="1B3355"/>
+                    </a:solidFill>
+                  </a:tcPr>
+                </a:tc>
+              </a:tr>
+              <a:tr h="365760">
+                <a:tc>
+                  <a:txBody>
+                    <a:bodyPr/>
+                    <a:lstStyle/>
+                    <a:p>
+                      <a:pPr algn="l"/>
+                      <a:r>
+                        <a:rPr sz="1150" b="1">
+                          <a:solidFill>
+                            <a:srgbClr val="1B3355"/>
+                          </a:solidFill>
+                        </a:rPr>
+                        <a:t>A · Direct swap by all holders</a:t>
+                      </a:r>
+                    </a:p>
+                  </a:txBody>
+                  <a:tcPr>
+                    <a:solidFill>
+                      <a:srgbClr val="ECF2F7"/>
+                    </a:solidFill>
+                  </a:tcPr>
+                </a:tc>
+                <a:tc>
+                  <a:txBody>
+                    <a:bodyPr/>
+                    <a:lstStyle/>
+                    <a:p>
+                      <a:pPr algn="ctr"/>
+                      <a:r>
+                        <a:rPr sz="1150" b="0">
+                          <a:solidFill>
+                            <a:srgbClr val="1B3355"/>
+                          </a:solidFill>
+                        </a:rPr>
+                        <a:t>Each Korean shareholder files and is taxed individually at the exchange</a:t>
+                      </a:r>
+                    </a:p>
+                  </a:txBody>
+                  <a:tcPr>
+                    <a:solidFill>
+                      <a:srgbClr val="ECF2F7"/>
+                    </a:solidFill>
+                  </a:tcPr>
+                </a:tc>
+                <a:tc>
+                  <a:txBody>
+                    <a:bodyPr/>
+                    <a:lstStyle/>
+                    <a:p>
+                      <a:pPr algn="ctr"/>
+                      <a:r>
+                        <a:rPr sz="1150" b="0">
+                          <a:solidFill>
+                            <a:srgbClr val="1B3355"/>
+                          </a:solidFill>
+                        </a:rPr>
+                        <a:t>Heaviest friction — the problem rightly being avoided</a:t>
+                      </a:r>
+                    </a:p>
+                  </a:txBody>
+                  <a:tcPr>
+                    <a:solidFill>
+                      <a:srgbClr val="ECF2F7"/>
+                    </a:solidFill>
+                  </a:tcPr>
+                </a:tc>
+              </a:tr>
+              <a:tr h="365760">
+                <a:tc>
+                  <a:txBody>
+                    <a:bodyPr/>
+                    <a:lstStyle/>
+                    <a:p>
+                      <a:pPr algn="l"/>
+                      <a:r>
+                        <a:rPr sz="1150" b="1">
+                          <a:solidFill>
+                            <a:srgbClr val="1B3355"/>
+                          </a:solidFill>
+                        </a:rPr>
+                        <a:t>B · Holdco block entry (recommended)</a:t>
+                      </a:r>
+                    </a:p>
+                  </a:txBody>
+                  <a:tcPr>
+                    <a:solidFill>
+                      <a:srgbClr val="FFFFFF"/>
+                    </a:solidFill>
+                  </a:tcPr>
+                </a:tc>
+                <a:tc>
+                  <a:txBody>
+                    <a:bodyPr/>
+                    <a:lstStyle/>
+                    <a:p>
+                      <a:pPr algn="ctr"/>
+                      <a:r>
+                        <a:rPr sz="1150" b="1">
+                          <a:solidFill>
+                            <a:srgbClr val="1B3355"/>
+                          </a:solidFill>
+                        </a:rPr>
+                        <a:t>One exchange into the Cayman holdco at the LOW pre-listing value; one collective FX filing via the FA; the later platform swap happens at holdco level — no second Korean event</a:t>
+                      </a:r>
+                    </a:p>
+                  </a:txBody>
+                  <a:tcPr>
+                    <a:solidFill>
+                      <a:srgbClr val="FFFFFF"/>
+                    </a:solidFill>
+                  </a:tcPr>
+                </a:tc>
+                <a:tc>
+                  <a:txBody>
+                    <a:bodyPr/>
+                    <a:lstStyle/>
+                    <a:p>
+                      <a:pPr algn="ctr"/>
+                      <a:r>
+                        <a:rPr sz="1150" b="1">
+                          <a:solidFill>
+                            <a:srgbClr val="1B3355"/>
+                          </a:solidFill>
+                        </a:rPr>
+                        <a:t>Tax/FX objective achieved AND automatic pro-rata fairness — what the Cayman structure exists for</a:t>
+                      </a:r>
+                    </a:p>
+                  </a:txBody>
+                  <a:tcPr>
+                    <a:solidFill>
+                      <a:srgbClr val="FFFFFF"/>
+                    </a:solidFill>
+                  </a:tcPr>
+                </a:tc>
+              </a:tr>
+              <a:tr h="365760">
+                <a:tc>
+                  <a:txBody>
+                    <a:bodyPr/>
+                    <a:lstStyle/>
+                    <a:p>
+                      <a:pPr algn="l"/>
+                      <a:r>
+                        <a:rPr sz="1150" b="1">
+                          <a:solidFill>
+                            <a:srgbClr val="1B3355"/>
+                          </a:solidFill>
+                        </a:rPr>
+                        <a:t>C · Individuals first — documented</a:t>
+                      </a:r>
+                    </a:p>
+                  </a:txBody>
+                  <a:tcPr>
+                    <a:solidFill>
+                      <a:srgbClr val="ECF2F7"/>
+                    </a:solidFill>
+                  </a:tcPr>
+                </a:tc>
+                <a:tc>
+                  <a:txBody>
+                    <a:bodyPr/>
+                    <a:lstStyle/>
+                    <a:p>
+                      <a:pPr algn="ctr"/>
+                      <a:r>
+                        <a:rPr sz="1150" b="0">
+                          <a:solidFill>
+                            <a:srgbClr val="1B3355"/>
+                          </a:solidFill>
+                        </a:rPr>
+                        <a:t>Written nominee/escrow declaration + annexed pro-rata schedule + deadline transfer into the holdco at the SAME valuation + Korean tax opinion (deemed-gift exposure) + SEC beneficial-ownership disclosure</a:t>
+                      </a:r>
+                    </a:p>
+                  </a:txBody>
+                  <a:tcPr>
+                    <a:solidFill>
+                      <a:srgbClr val="ECF2F7"/>
+                    </a:solidFill>
+                  </a:tcPr>
+                </a:tc>
+                <a:tc>
+                  <a:txBody>
+                    <a:bodyPr/>
+                    <a:lstStyle/>
+                    <a:p>
+                      <a:pPr algn="ctr"/>
+                      <a:r>
+                        <a:rPr sz="1150" b="0">
+                          <a:solidFill>
+                            <a:srgbClr val="1B3355"/>
+                          </a:solidFill>
+                        </a:rPr>
+                        <a:t>Workable as a bridge; undocumented it creates deemed-gift tax, a larger second-step tax at listed prices, and personal risk for the two principals</a:t>
+                      </a:r>
+                    </a:p>
+                  </a:txBody>
+                  <a:tcPr>
+                    <a:solidFill>
+                      <a:srgbClr val="ECF2F7"/>
+                    </a:solidFill>
+                  </a:tcPr>
+                </a:tc>
+              </a:tr>
+            </a:tbl>
+          </a:graphicData>
+        </a:graphic>
+      </p:graphicFrame>
+      <p:sp>
+        <p:nvSpPr>
+          <p:cNvPr id="9" name="Rounded Rectangle 8"/>
+          <p:cNvSpPr/>
+          <p:nvPr/>
+        </p:nvSpPr>
+        <p:spPr>
+          <a:xfrm>
+            <a:off x="640080" y="5806440"/>
+            <a:ext cx="10927080" cy="731520"/>
+          </a:xfrm>
+          <a:prstGeom prst="roundRect">
+            <a:avLst/>
+          </a:prstGeom>
+          <a:solidFill>
+            <a:srgbClr val="ECF2F7"/>
+          </a:solidFill>
+          <a:ln>
+            <a:noFill/>
+          </a:ln>
+          <a:effectLst/>
+        </p:spPr>
+        <p:style>
+          <a:lnRef idx="1">
+            <a:schemeClr val="accent1"/>
+          </a:lnRef>
+          <a:fillRef idx="3">
+            <a:schemeClr val="accent1"/>
+          </a:fillRef>
+          <a:effectRef idx="2">
+            <a:schemeClr val="accent1"/>
+          </a:effectRef>
+          <a:fontRef idx="minor">
+            <a:schemeClr val="lt1"/>
+          </a:fontRef>
+        </p:style>
+        <p:txBody>
+          <a:bodyPr rtlCol="0" anchor="ctr" wrap="square" lIns="76200" rIns="76200" tIns="38100" bIns="38100"/>
+          <a:lstStyle/>
+          <a:p>
+            <a:pPr algn="ctr"/>
+            <a:r>
+              <a:rPr sz="1450" b="1">
+                <a:solidFill>
+                  <a:srgbClr val="1B3355"/>
+                </a:solidFill>
+                <a:latin typeface="Calibri"/>
+              </a:rPr>
+              <a:t>All Korean tax and FX statements to be confirmed in writing by Korean counsel before any structure is selected.</a:t>
+            </a:r>
+          </a:p>
+        </p:txBody>
+      </p:sp>
+    </p:spTree>
+  </p:cSld>
+  <p:clrMapOvr>
+    <a:masterClrMapping/>
+  </p:clrMapOvr>
+</p:sld>
+</file>
+
+<file path=ppt/slides/slide12.xml><?xml version="1.0" encoding="utf-8"?>
+<p:sld xmlns:a="http://schemas.openxmlformats.org/drawingml/2006/main" xmlns:p="http://schemas.openxmlformats.org/presentationml/2006/main" xmlns:r="http://schemas.openxmlformats.org/officeDocument/2006/relationships">
+  <p:cSld>
+    <p:spTree>
+      <p:nvGrpSpPr>
+        <p:cNvPr id="1" name=""/>
+        <p:cNvGrpSpPr/>
+        <p:nvPr/>
+      </p:nvGrpSpPr>
+      <p:grpSpPr/>
+      <p:sp>
+        <p:nvSpPr>
+          <p:cNvPr id="2" name="Rectangle 1"/>
+          <p:cNvSpPr/>
+          <p:nvPr/>
+        </p:nvSpPr>
+        <p:spPr>
+          <a:xfrm>
+            <a:off x="0" y="0"/>
+            <a:ext cx="12191695" cy="1097280"/>
+          </a:xfrm>
+          <a:prstGeom prst="rect">
+            <a:avLst/>
+          </a:prstGeom>
+          <a:solidFill>
+            <a:srgbClr val="1B3355"/>
+          </a:solidFill>
+          <a:ln>
+            <a:noFill/>
+          </a:ln>
+          <a:effectLst/>
+        </p:spPr>
+        <p:style>
+          <a:lnRef idx="1">
+            <a:schemeClr val="accent1"/>
+          </a:lnRef>
+          <a:fillRef idx="3">
+            <a:schemeClr val="accent1"/>
+          </a:fillRef>
+          <a:effectRef idx="2">
+            <a:schemeClr val="accent1"/>
+          </a:effectRef>
+          <a:fontRef idx="minor">
+            <a:schemeClr val="lt1"/>
+          </a:fontRef>
+        </p:style>
+        <p:txBody>
+          <a:bodyPr rtlCol="0" anchor="ctr"/>
+          <a:lstStyle/>
+          <a:p>
+            <a:pPr algn="ctr"/>
+          </a:p>
+        </p:txBody>
+      </p:sp>
+      <p:sp>
+        <p:nvSpPr>
+          <p:cNvPr id="3" name="Rectangle 2"/>
+          <p:cNvSpPr/>
+          <p:nvPr/>
+        </p:nvSpPr>
+        <p:spPr>
+          <a:xfrm>
+            <a:off x="502920" y="310896"/>
+            <a:ext cx="128016" cy="475488"/>
+          </a:xfrm>
+          <a:prstGeom prst="rect">
+            <a:avLst/>
+          </a:prstGeom>
+          <a:solidFill>
+            <a:srgbClr val="2E86C1"/>
+          </a:solidFill>
+          <a:ln>
+            <a:noFill/>
+          </a:ln>
+          <a:effectLst/>
+        </p:spPr>
+        <p:style>
+          <a:lnRef idx="1">
+            <a:schemeClr val="accent1"/>
+          </a:lnRef>
+          <a:fillRef idx="3">
+            <a:schemeClr val="accent1"/>
+          </a:fillRef>
+          <a:effectRef idx="2">
+            <a:schemeClr val="accent1"/>
+          </a:effectRef>
+          <a:fontRef idx="minor">
+            <a:schemeClr val="lt1"/>
+          </a:fontRef>
+        </p:style>
+        <p:txBody>
+          <a:bodyPr rtlCol="0" anchor="ctr"/>
+          <a:lstStyle/>
+          <a:p>
+            <a:pPr algn="ctr"/>
+          </a:p>
+        </p:txBody>
+      </p:sp>
+      <p:sp>
+        <p:nvSpPr>
+          <p:cNvPr id="4" name="TextBox 3"/>
+          <p:cNvSpPr txBox="1"/>
+          <p:nvPr/>
+        </p:nvSpPr>
+        <p:spPr>
+          <a:xfrm>
+            <a:off x="777240" y="164592"/>
+            <a:ext cx="10607040" cy="822960"/>
+          </a:xfrm>
+          <a:prstGeom prst="rect">
+            <a:avLst/>
+          </a:prstGeom>
+          <a:noFill/>
+        </p:spPr>
+        <p:txBody>
+          <a:bodyPr wrap="square" anchor="ctr">
+            <a:spAutoFit/>
+          </a:bodyPr>
+          <a:lstStyle/>
+          <a:p>
+            <a:pPr algn="l">
+              <a:spcAft>
+                <a:spcPts val="400"/>
+              </a:spcAft>
+            </a:pPr>
+            <a:r>
+              <a:rPr sz="2700" b="1">
+                <a:solidFill>
+                  <a:srgbClr val="FFFFFF"/>
+                </a:solidFill>
+                <a:latin typeface="Calibri"/>
+              </a:rPr>
+              <a:t>Recommended shareholding structure</a:t>
+            </a:r>
+          </a:p>
+        </p:txBody>
+      </p:sp>
+      <p:sp>
+        <p:nvSpPr>
+          <p:cNvPr id="5" name="TextBox 4"/>
+          <p:cNvSpPr txBox="1"/>
+          <p:nvPr/>
+        </p:nvSpPr>
+        <p:spPr>
+          <a:xfrm>
+            <a:off x="795528" y="786384"/>
+            <a:ext cx="10607040" cy="274320"/>
+          </a:xfrm>
+          <a:prstGeom prst="rect">
+            <a:avLst/>
+          </a:prstGeom>
+          <a:noFill/>
+        </p:spPr>
+        <p:txBody>
+          <a:bodyPr wrap="square" anchor="t">
+            <a:spAutoFit/>
+          </a:bodyPr>
+          <a:lstStyle/>
+          <a:p>
+            <a:pPr algn="l">
+              <a:spcAft>
+                <a:spcPts val="400"/>
+              </a:spcAft>
+            </a:pPr>
+            <a:r>
+              <a:rPr sz="1400" b="0">
+                <a:solidFill>
+                  <a:srgbClr val="CFDDEA"/>
+                </a:solidFill>
+                <a:latin typeface="Calibri"/>
+              </a:rPr>
+              <a:t>FVH's structure is undetermined — set it by value, enter as one block</a:t>
+            </a:r>
+          </a:p>
+        </p:txBody>
+      </p:sp>
+      <p:sp>
+        <p:nvSpPr>
+          <p:cNvPr id="6" name="TextBox 5"/>
+          <p:cNvSpPr txBox="1"/>
+          <p:nvPr/>
+        </p:nvSpPr>
+        <p:spPr>
+          <a:xfrm>
+            <a:off x="11338560" y="6437376"/>
+            <a:ext cx="731520" cy="320040"/>
+          </a:xfrm>
+          <a:prstGeom prst="rect">
+            <a:avLst/>
+          </a:prstGeom>
+          <a:noFill/>
+        </p:spPr>
+        <p:txBody>
+          <a:bodyPr wrap="square" anchor="t">
+            <a:spAutoFit/>
+          </a:bodyPr>
+          <a:lstStyle/>
+          <a:p>
+            <a:pPr algn="r">
+              <a:spcAft>
+                <a:spcPts val="400"/>
+              </a:spcAft>
+            </a:pPr>
+            <a:r>
+              <a:rPr sz="1200" b="0">
+                <a:solidFill>
+                  <a:srgbClr val="5A5A5A"/>
+                </a:solidFill>
+                <a:latin typeface="Calibri"/>
+              </a:rPr>
+              <a:t>12</a:t>
             </a:r>
           </a:p>
         </p:txBody>
@@ -5636,7 +6282,7 @@
 </p:sld>
 </file>
 
-<file path=ppt/slides/slide12.xml><?xml version="1.0" encoding="utf-8"?>
+<file path=ppt/slides/slide13.xml><?xml version="1.0" encoding="utf-8"?>
 <p:sld xmlns:a="http://schemas.openxmlformats.org/drawingml/2006/main" xmlns:p="http://schemas.openxmlformats.org/presentationml/2006/main" xmlns:r="http://schemas.openxmlformats.org/officeDocument/2006/relationships">
   <p:cSld>
     <p:spTree>
@@ -5846,7 +6492,7 @@
                 </a:solidFill>
                 <a:latin typeface="Calibri"/>
               </a:rPr>
-              <a:t>12</a:t>
+              <a:t>13</a:t>
             </a:r>
           </a:p>
         </p:txBody>
@@ -6461,809 +7107,6 @@
 </p:sld>
 </file>
 
-<file path=ppt/slides/slide13.xml><?xml version="1.0" encoding="utf-8"?>
-<p:sld xmlns:a="http://schemas.openxmlformats.org/drawingml/2006/main" xmlns:p="http://schemas.openxmlformats.org/presentationml/2006/main" xmlns:r="http://schemas.openxmlformats.org/officeDocument/2006/relationships">
-  <p:cSld>
-    <p:spTree>
-      <p:nvGrpSpPr>
-        <p:cNvPr id="1" name=""/>
-        <p:cNvGrpSpPr/>
-        <p:nvPr/>
-      </p:nvGrpSpPr>
-      <p:grpSpPr/>
-      <p:sp>
-        <p:nvSpPr>
-          <p:cNvPr id="2" name="Rectangle 1"/>
-          <p:cNvSpPr/>
-          <p:nvPr/>
-        </p:nvSpPr>
-        <p:spPr>
-          <a:xfrm>
-            <a:off x="0" y="0"/>
-            <a:ext cx="12191695" cy="1097280"/>
-          </a:xfrm>
-          <a:prstGeom prst="rect">
-            <a:avLst/>
-          </a:prstGeom>
-          <a:solidFill>
-            <a:srgbClr val="1B3355"/>
-          </a:solidFill>
-          <a:ln>
-            <a:noFill/>
-          </a:ln>
-          <a:effectLst/>
-        </p:spPr>
-        <p:style>
-          <a:lnRef idx="1">
-            <a:schemeClr val="accent1"/>
-          </a:lnRef>
-          <a:fillRef idx="3">
-            <a:schemeClr val="accent1"/>
-          </a:fillRef>
-          <a:effectRef idx="2">
-            <a:schemeClr val="accent1"/>
-          </a:effectRef>
-          <a:fontRef idx="minor">
-            <a:schemeClr val="lt1"/>
-          </a:fontRef>
-        </p:style>
-        <p:txBody>
-          <a:bodyPr rtlCol="0" anchor="ctr"/>
-          <a:lstStyle/>
-          <a:p>
-            <a:pPr algn="ctr"/>
-          </a:p>
-        </p:txBody>
-      </p:sp>
-      <p:sp>
-        <p:nvSpPr>
-          <p:cNvPr id="3" name="Rectangle 2"/>
-          <p:cNvSpPr/>
-          <p:nvPr/>
-        </p:nvSpPr>
-        <p:spPr>
-          <a:xfrm>
-            <a:off x="502920" y="310896"/>
-            <a:ext cx="128016" cy="475488"/>
-          </a:xfrm>
-          <a:prstGeom prst="rect">
-            <a:avLst/>
-          </a:prstGeom>
-          <a:solidFill>
-            <a:srgbClr val="2E86C1"/>
-          </a:solidFill>
-          <a:ln>
-            <a:noFill/>
-          </a:ln>
-          <a:effectLst/>
-        </p:spPr>
-        <p:style>
-          <a:lnRef idx="1">
-            <a:schemeClr val="accent1"/>
-          </a:lnRef>
-          <a:fillRef idx="3">
-            <a:schemeClr val="accent1"/>
-          </a:fillRef>
-          <a:effectRef idx="2">
-            <a:schemeClr val="accent1"/>
-          </a:effectRef>
-          <a:fontRef idx="minor">
-            <a:schemeClr val="lt1"/>
-          </a:fontRef>
-        </p:style>
-        <p:txBody>
-          <a:bodyPr rtlCol="0" anchor="ctr"/>
-          <a:lstStyle/>
-          <a:p>
-            <a:pPr algn="ctr"/>
-          </a:p>
-        </p:txBody>
-      </p:sp>
-      <p:sp>
-        <p:nvSpPr>
-          <p:cNvPr id="4" name="TextBox 3"/>
-          <p:cNvSpPr txBox="1"/>
-          <p:nvPr/>
-        </p:nvSpPr>
-        <p:spPr>
-          <a:xfrm>
-            <a:off x="777240" y="164592"/>
-            <a:ext cx="10607040" cy="822960"/>
-          </a:xfrm>
-          <a:prstGeom prst="rect">
-            <a:avLst/>
-          </a:prstGeom>
-          <a:noFill/>
-        </p:spPr>
-        <p:txBody>
-          <a:bodyPr wrap="square" anchor="ctr">
-            <a:spAutoFit/>
-          </a:bodyPr>
-          <a:lstStyle/>
-          <a:p>
-            <a:pPr algn="l">
-              <a:spcAft>
-                <a:spcPts val="400"/>
-              </a:spcAft>
-            </a:pPr>
-            <a:r>
-              <a:rPr sz="2700" b="1">
-                <a:solidFill>
-                  <a:srgbClr val="FFFFFF"/>
-                </a:solidFill>
-                <a:latin typeface="Calibri"/>
-              </a:rPr>
-              <a:t>What this means for WBI shareholders</a:t>
-            </a:r>
-          </a:p>
-        </p:txBody>
-      </p:sp>
-      <p:sp>
-        <p:nvSpPr>
-          <p:cNvPr id="5" name="TextBox 4"/>
-          <p:cNvSpPr txBox="1"/>
-          <p:nvPr/>
-        </p:nvSpPr>
-        <p:spPr>
-          <a:xfrm>
-            <a:off x="795528" y="786384"/>
-            <a:ext cx="10607040" cy="274320"/>
-          </a:xfrm>
-          <a:prstGeom prst="rect">
-            <a:avLst/>
-          </a:prstGeom>
-          <a:noFill/>
-        </p:spPr>
-        <p:txBody>
-          <a:bodyPr wrap="square" anchor="t">
-            <a:spAutoFit/>
-          </a:bodyPr>
-          <a:lstStyle/>
-          <a:p>
-            <a:pPr algn="l">
-              <a:spcAft>
-                <a:spcPts val="400"/>
-              </a:spcAft>
-            </a:pPr>
-            <a:r>
-              <a:rPr sz="1400" b="0">
-                <a:solidFill>
-                  <a:srgbClr val="CFDDEA"/>
-                </a:solidFill>
-                <a:latin typeface="Calibri"/>
-              </a:rPr>
-              <a:t>Your 49% of GenApep, traced through both routes</a:t>
-            </a:r>
-          </a:p>
-        </p:txBody>
-      </p:sp>
-      <p:sp>
-        <p:nvSpPr>
-          <p:cNvPr id="6" name="TextBox 5"/>
-          <p:cNvSpPr txBox="1"/>
-          <p:nvPr/>
-        </p:nvSpPr>
-        <p:spPr>
-          <a:xfrm>
-            <a:off x="11338560" y="6437376"/>
-            <a:ext cx="731520" cy="320040"/>
-          </a:xfrm>
-          <a:prstGeom prst="rect">
-            <a:avLst/>
-          </a:prstGeom>
-          <a:noFill/>
-        </p:spPr>
-        <p:txBody>
-          <a:bodyPr wrap="square" anchor="t">
-            <a:spAutoFit/>
-          </a:bodyPr>
-          <a:lstStyle/>
-          <a:p>
-            <a:pPr algn="r">
-              <a:spcAft>
-                <a:spcPts val="400"/>
-              </a:spcAft>
-            </a:pPr>
-            <a:r>
-              <a:rPr sz="1200" b="0">
-                <a:solidFill>
-                  <a:srgbClr val="5A5A5A"/>
-                </a:solidFill>
-                <a:latin typeface="Calibri"/>
-              </a:rPr>
-              <a:t>13</a:t>
-            </a:r>
-          </a:p>
-        </p:txBody>
-      </p:sp>
-      <p:sp>
-        <p:nvSpPr>
-          <p:cNvPr id="7" name="Rounded Rectangle 6"/>
-          <p:cNvSpPr/>
-          <p:nvPr/>
-        </p:nvSpPr>
-        <p:spPr>
-          <a:xfrm>
-            <a:off x="640080" y="1554480"/>
-            <a:ext cx="2606040" cy="1965960"/>
-          </a:xfrm>
-          <a:prstGeom prst="roundRect">
-            <a:avLst/>
-          </a:prstGeom>
-          <a:solidFill>
-            <a:srgbClr val="2E86C1"/>
-          </a:solidFill>
-          <a:ln>
-            <a:noFill/>
-          </a:ln>
-        </p:spPr>
-        <p:style>
-          <a:lnRef idx="1">
-            <a:schemeClr val="accent1"/>
-          </a:lnRef>
-          <a:fillRef idx="3">
-            <a:schemeClr val="accent1"/>
-          </a:fillRef>
-          <a:effectRef idx="2">
-            <a:schemeClr val="accent1"/>
-          </a:effectRef>
-          <a:fontRef idx="minor">
-            <a:schemeClr val="lt1"/>
-          </a:fontRef>
-        </p:style>
-        <p:txBody>
-          <a:bodyPr rtlCol="0" anchor="ctr" wrap="square" lIns="76200" rIns="76200" tIns="38100" bIns="38100"/>
-          <a:lstStyle/>
-          <a:p>
-            <a:pPr algn="ctr"/>
-            <a:r>
-              <a:rPr sz="1400" b="1">
-                <a:solidFill>
-                  <a:srgbClr val="CFDDEA"/>
-                </a:solidFill>
-                <a:latin typeface="Calibri"/>
-              </a:rPr>
-              <a:t>Today</a:t>
-            </a:r>
-          </a:p>
-          <a:p>
-            <a:pPr algn="ctr"/>
-            <a:r>
-              <a:rPr sz="3000" b="1">
-                <a:solidFill>
-                  <a:srgbClr val="FFFFFF"/>
-                </a:solidFill>
-                <a:latin typeface="Calibri"/>
-              </a:rPr>
-              <a:t>49%</a:t>
-            </a:r>
-          </a:p>
-          <a:p>
-            <a:pPr algn="ctr"/>
-            <a:r>
-              <a:rPr sz="1150" b="0">
-                <a:solidFill>
-                  <a:srgbClr val="FFFFFF"/>
-                </a:solidFill>
-                <a:latin typeface="Calibri"/>
-              </a:rPr>
-              <a:t>of GenApep · ≈ $17.2M at $35M mid</a:t>
-            </a:r>
-          </a:p>
-        </p:txBody>
-      </p:sp>
-      <p:sp>
-        <p:nvSpPr>
-          <p:cNvPr id="8" name="Right Arrow 7"/>
-          <p:cNvSpPr/>
-          <p:nvPr/>
-        </p:nvSpPr>
-        <p:spPr>
-          <a:xfrm>
-            <a:off x="3264408" y="2331720"/>
-            <a:ext cx="182880" cy="411480"/>
-          </a:xfrm>
-          <a:prstGeom prst="rightArrow">
-            <a:avLst/>
-          </a:prstGeom>
-          <a:solidFill>
-            <a:srgbClr val="5A5A5A"/>
-          </a:solidFill>
-          <a:ln>
-            <a:noFill/>
-          </a:ln>
-          <a:effectLst/>
-        </p:spPr>
-        <p:style>
-          <a:lnRef idx="1">
-            <a:schemeClr val="accent1"/>
-          </a:lnRef>
-          <a:fillRef idx="3">
-            <a:schemeClr val="accent1"/>
-          </a:fillRef>
-          <a:effectRef idx="2">
-            <a:schemeClr val="accent1"/>
-          </a:effectRef>
-          <a:fontRef idx="minor">
-            <a:schemeClr val="lt1"/>
-          </a:fontRef>
-        </p:style>
-        <p:txBody>
-          <a:bodyPr rtlCol="0" anchor="ctr"/>
-          <a:lstStyle/>
-          <a:p>
-            <a:pPr algn="ctr"/>
-          </a:p>
-        </p:txBody>
-      </p:sp>
-      <p:sp>
-        <p:nvSpPr>
-          <p:cNvPr id="9" name="Rounded Rectangle 8"/>
-          <p:cNvSpPr/>
-          <p:nvPr/>
-        </p:nvSpPr>
-        <p:spPr>
-          <a:xfrm>
-            <a:off x="3456432" y="1554480"/>
-            <a:ext cx="2606040" cy="1965960"/>
-          </a:xfrm>
-          <a:prstGeom prst="roundRect">
-            <a:avLst/>
-          </a:prstGeom>
-          <a:solidFill>
-            <a:srgbClr val="1AA19C"/>
-          </a:solidFill>
-          <a:ln>
-            <a:noFill/>
-          </a:ln>
-        </p:spPr>
-        <p:style>
-          <a:lnRef idx="1">
-            <a:schemeClr val="accent1"/>
-          </a:lnRef>
-          <a:fillRef idx="3">
-            <a:schemeClr val="accent1"/>
-          </a:fillRef>
-          <a:effectRef idx="2">
-            <a:schemeClr val="accent1"/>
-          </a:effectRef>
-          <a:fontRef idx="minor">
-            <a:schemeClr val="lt1"/>
-          </a:fontRef>
-        </p:style>
-        <p:txBody>
-          <a:bodyPr rtlCol="0" anchor="ctr" wrap="square" lIns="76200" rIns="76200" tIns="38100" bIns="38100"/>
-          <a:lstStyle/>
-          <a:p>
-            <a:pPr algn="ctr"/>
-            <a:r>
-              <a:rPr sz="1400" b="1">
-                <a:solidFill>
-                  <a:srgbClr val="CFDDEA"/>
-                </a:solidFill>
-                <a:latin typeface="Calibri"/>
-              </a:rPr>
-              <a:t>After pool (7.5%)</a:t>
-            </a:r>
-          </a:p>
-          <a:p>
-            <a:pPr algn="ctr"/>
-            <a:r>
-              <a:rPr sz="3000" b="1">
-                <a:solidFill>
-                  <a:srgbClr val="FFFFFF"/>
-                </a:solidFill>
-                <a:latin typeface="Calibri"/>
-              </a:rPr>
-              <a:t>45.3%</a:t>
-            </a:r>
-          </a:p>
-          <a:p>
-            <a:pPr algn="ctr"/>
-            <a:r>
-              <a:rPr sz="1150" b="0">
-                <a:solidFill>
-                  <a:srgbClr val="FFFFFF"/>
-                </a:solidFill>
-                <a:latin typeface="Calibri"/>
-              </a:rPr>
-              <a:t>≈ $15.9M — before technology credit</a:t>
-            </a:r>
-          </a:p>
-        </p:txBody>
-      </p:sp>
-      <p:sp>
-        <p:nvSpPr>
-          <p:cNvPr id="10" name="Right Arrow 9"/>
-          <p:cNvSpPr/>
-          <p:nvPr/>
-        </p:nvSpPr>
-        <p:spPr>
-          <a:xfrm>
-            <a:off x="6080760" y="2331720"/>
-            <a:ext cx="182880" cy="411480"/>
-          </a:xfrm>
-          <a:prstGeom prst="rightArrow">
-            <a:avLst/>
-          </a:prstGeom>
-          <a:solidFill>
-            <a:srgbClr val="5A5A5A"/>
-          </a:solidFill>
-          <a:ln>
-            <a:noFill/>
-          </a:ln>
-          <a:effectLst/>
-        </p:spPr>
-        <p:style>
-          <a:lnRef idx="1">
-            <a:schemeClr val="accent1"/>
-          </a:lnRef>
-          <a:fillRef idx="3">
-            <a:schemeClr val="accent1"/>
-          </a:fillRef>
-          <a:effectRef idx="2">
-            <a:schemeClr val="accent1"/>
-          </a:effectRef>
-          <a:fontRef idx="minor">
-            <a:schemeClr val="lt1"/>
-          </a:fontRef>
-        </p:style>
-        <p:txBody>
-          <a:bodyPr rtlCol="0" anchor="ctr"/>
-          <a:lstStyle/>
-          <a:p>
-            <a:pPr algn="ctr"/>
-          </a:p>
-        </p:txBody>
-      </p:sp>
-      <p:sp>
-        <p:nvSpPr>
-          <p:cNvPr id="11" name="Rounded Rectangle 10"/>
-          <p:cNvSpPr/>
-          <p:nvPr/>
-        </p:nvSpPr>
-        <p:spPr>
-          <a:xfrm>
-            <a:off x="6272784" y="1554480"/>
-            <a:ext cx="2606040" cy="1965960"/>
-          </a:xfrm>
-          <a:prstGeom prst="roundRect">
-            <a:avLst/>
-          </a:prstGeom>
-          <a:solidFill>
-            <a:srgbClr val="E09E2B"/>
-          </a:solidFill>
-          <a:ln>
-            <a:noFill/>
-          </a:ln>
-        </p:spPr>
-        <p:style>
-          <a:lnRef idx="1">
-            <a:schemeClr val="accent1"/>
-          </a:lnRef>
-          <a:fillRef idx="3">
-            <a:schemeClr val="accent1"/>
-          </a:fillRef>
-          <a:effectRef idx="2">
-            <a:schemeClr val="accent1"/>
-          </a:effectRef>
-          <a:fontRef idx="minor">
-            <a:schemeClr val="lt1"/>
-          </a:fontRef>
-        </p:style>
-        <p:txBody>
-          <a:bodyPr rtlCol="0" anchor="ctr" wrap="square" lIns="76200" rIns="76200" tIns="38100" bIns="38100"/>
-          <a:lstStyle/>
-          <a:p>
-            <a:pPr algn="ctr"/>
-            <a:r>
-              <a:rPr sz="1400" b="1">
-                <a:solidFill>
-                  <a:srgbClr val="FFFFFF"/>
-                </a:solidFill>
-                <a:latin typeface="Calibri"/>
-              </a:rPr>
-              <a:t>Route B (FVH $10M)</a:t>
-            </a:r>
-          </a:p>
-          <a:p>
-            <a:pPr algn="ctr"/>
-            <a:r>
-              <a:rPr sz="3000" b="1">
-                <a:solidFill>
-                  <a:srgbClr val="FFFFFF"/>
-                </a:solidFill>
-                <a:latin typeface="Calibri"/>
-              </a:rPr>
-              <a:t>35.3%</a:t>
-            </a:r>
-          </a:p>
-          <a:p>
-            <a:pPr algn="ctr"/>
-            <a:r>
-              <a:rPr sz="1150" b="0">
-                <a:solidFill>
-                  <a:srgbClr val="FFFFFF"/>
-                </a:solidFill>
-                <a:latin typeface="Calibri"/>
-              </a:rPr>
-              <a:t>of the LISTED company · $28–35M if market values group at $80–100M</a:t>
-            </a:r>
-          </a:p>
-        </p:txBody>
-      </p:sp>
-      <p:sp>
-        <p:nvSpPr>
-          <p:cNvPr id="12" name="Right Arrow 11"/>
-          <p:cNvSpPr/>
-          <p:nvPr/>
-        </p:nvSpPr>
-        <p:spPr>
-          <a:xfrm>
-            <a:off x="8897112" y="2331720"/>
-            <a:ext cx="182880" cy="411480"/>
-          </a:xfrm>
-          <a:prstGeom prst="rightArrow">
-            <a:avLst/>
-          </a:prstGeom>
-          <a:solidFill>
-            <a:srgbClr val="5A5A5A"/>
-          </a:solidFill>
-          <a:ln>
-            <a:noFill/>
-          </a:ln>
-          <a:effectLst/>
-        </p:spPr>
-        <p:style>
-          <a:lnRef idx="1">
-            <a:schemeClr val="accent1"/>
-          </a:lnRef>
-          <a:fillRef idx="3">
-            <a:schemeClr val="accent1"/>
-          </a:fillRef>
-          <a:effectRef idx="2">
-            <a:schemeClr val="accent1"/>
-          </a:effectRef>
-          <a:fontRef idx="minor">
-            <a:schemeClr val="lt1"/>
-          </a:fontRef>
-        </p:style>
-        <p:txBody>
-          <a:bodyPr rtlCol="0" anchor="ctr"/>
-          <a:lstStyle/>
-          <a:p>
-            <a:pPr algn="ctr"/>
-          </a:p>
-        </p:txBody>
-      </p:sp>
-      <p:sp>
-        <p:nvSpPr>
-          <p:cNvPr id="13" name="Rounded Rectangle 12"/>
-          <p:cNvSpPr/>
-          <p:nvPr/>
-        </p:nvSpPr>
-        <p:spPr>
-          <a:xfrm>
-            <a:off x="9089136" y="1554480"/>
-            <a:ext cx="2606040" cy="1965960"/>
-          </a:xfrm>
-          <a:prstGeom prst="roundRect">
-            <a:avLst/>
-          </a:prstGeom>
-          <a:solidFill>
-            <a:srgbClr val="1B3355"/>
-          </a:solidFill>
-          <a:ln>
-            <a:noFill/>
-          </a:ln>
-        </p:spPr>
-        <p:style>
-          <a:lnRef idx="1">
-            <a:schemeClr val="accent1"/>
-          </a:lnRef>
-          <a:fillRef idx="3">
-            <a:schemeClr val="accent1"/>
-          </a:fillRef>
-          <a:effectRef idx="2">
-            <a:schemeClr val="accent1"/>
-          </a:effectRef>
-          <a:fontRef idx="minor">
-            <a:schemeClr val="lt1"/>
-          </a:fontRef>
-        </p:style>
-        <p:txBody>
-          <a:bodyPr rtlCol="0" anchor="ctr" wrap="square" lIns="76200" rIns="76200" tIns="38100" bIns="38100"/>
-          <a:lstStyle/>
-          <a:p>
-            <a:pPr algn="ctr"/>
-            <a:r>
-              <a:rPr sz="1400" b="1">
-                <a:solidFill>
-                  <a:srgbClr val="CFDDEA"/>
-                </a:solidFill>
-                <a:latin typeface="Calibri"/>
-              </a:rPr>
-              <a:t>Route A post-IPO</a:t>
-            </a:r>
-          </a:p>
-          <a:p>
-            <a:pPr algn="ctr"/>
-            <a:r>
-              <a:rPr sz="3000" b="1">
-                <a:solidFill>
-                  <a:srgbClr val="FFFFFF"/>
-                </a:solidFill>
-                <a:latin typeface="Calibri"/>
-              </a:rPr>
-              <a:t>36.3%</a:t>
-            </a:r>
-          </a:p>
-          <a:p>
-            <a:pPr algn="ctr"/>
-            <a:r>
-              <a:rPr sz="1150" b="0">
-                <a:solidFill>
-                  <a:srgbClr val="FFFFFF"/>
-                </a:solidFill>
-                <a:latin typeface="Calibri"/>
-              </a:rPr>
-              <a:t>≈ $36.3M at $80M pre + $20M raise (workbook)</a:t>
-            </a:r>
-          </a:p>
-        </p:txBody>
-      </p:sp>
-      <p:sp>
-        <p:nvSpPr>
-          <p:cNvPr id="14" name="Rounded Rectangle 13"/>
-          <p:cNvSpPr/>
-          <p:nvPr/>
-        </p:nvSpPr>
-        <p:spPr>
-          <a:xfrm>
-            <a:off x="640080" y="3794760"/>
-            <a:ext cx="5394960" cy="2331720"/>
-          </a:xfrm>
-          <a:prstGeom prst="roundRect">
-            <a:avLst/>
-          </a:prstGeom>
-          <a:solidFill>
-            <a:srgbClr val="FFFFFF"/>
-          </a:solidFill>
-          <a:ln w="19050">
-            <a:solidFill>
-              <a:srgbClr val="2E86C1"/>
-            </a:solidFill>
-          </a:ln>
-        </p:spPr>
-        <p:style>
-          <a:lnRef idx="1">
-            <a:schemeClr val="accent1"/>
-          </a:lnRef>
-          <a:fillRef idx="3">
-            <a:schemeClr val="accent1"/>
-          </a:fillRef>
-          <a:effectRef idx="2">
-            <a:schemeClr val="accent1"/>
-          </a:effectRef>
-          <a:fontRef idx="minor">
-            <a:schemeClr val="lt1"/>
-          </a:fontRef>
-        </p:style>
-        <p:txBody>
-          <a:bodyPr rtlCol="0" anchor="t" wrap="square" lIns="127000" rIns="127000" tIns="101600"/>
-          <a:lstStyle/>
-          <a:p>
-            <a:pPr algn="l"/>
-            <a:r>
-              <a:rPr sz="1700" b="1">
-                <a:solidFill>
-                  <a:srgbClr val="1B3355"/>
-                </a:solidFill>
-                <a:latin typeface="Calibri"/>
-              </a:rPr>
-              <a:t>Where WBI's value comes from</a:t>
-            </a:r>
-          </a:p>
-          <a:p>
-            <a:pPr algn="l">
-              <a:spcBef>
-                <a:spcPts val="400"/>
-              </a:spcBef>
-            </a:pPr>
-            <a:r>
-              <a:rPr sz="1350">
-                <a:solidFill>
-                  <a:srgbClr val="5A5A5A"/>
-                </a:solidFill>
-                <a:latin typeface="Calibri"/>
-              </a:rPr>
-              <a:t>• MM Studio — WBI's growth engine: $2.9M → $36.3M by 2030, the plan's biggest swing factor.
-• WBI core exports: $4.69M in 2026, +20%/yr, NTS-certified FY2025 base.
-• Technology upside (AI.pep, DPW licence) accrues inside GenApep — you participate via the block.</a:t>
-            </a:r>
-          </a:p>
-        </p:txBody>
-      </p:sp>
-      <p:sp>
-        <p:nvSpPr>
-          <p:cNvPr id="15" name="Rounded Rectangle 14"/>
-          <p:cNvSpPr/>
-          <p:nvPr/>
-        </p:nvSpPr>
-        <p:spPr>
-          <a:xfrm>
-            <a:off x="6263640" y="3794760"/>
-            <a:ext cx="5303520" cy="2331720"/>
-          </a:xfrm>
-          <a:prstGeom prst="roundRect">
-            <a:avLst/>
-          </a:prstGeom>
-          <a:solidFill>
-            <a:srgbClr val="FFFFFF"/>
-          </a:solidFill>
-          <a:ln w="19050">
-            <a:solidFill>
-              <a:srgbClr val="C0392B"/>
-            </a:solidFill>
-          </a:ln>
-        </p:spPr>
-        <p:style>
-          <a:lnRef idx="1">
-            <a:schemeClr val="accent1"/>
-          </a:lnRef>
-          <a:fillRef idx="3">
-            <a:schemeClr val="accent1"/>
-          </a:fillRef>
-          <a:effectRef idx="2">
-            <a:schemeClr val="accent1"/>
-          </a:effectRef>
-          <a:fontRef idx="minor">
-            <a:schemeClr val="lt1"/>
-          </a:fontRef>
-        </p:style>
-        <p:txBody>
-          <a:bodyPr rtlCol="0" anchor="t" wrap="square" lIns="127000" rIns="127000" tIns="101600"/>
-          <a:lstStyle/>
-          <a:p>
-            <a:pPr algn="l"/>
-            <a:r>
-              <a:rPr sz="1700" b="1">
-                <a:solidFill>
-                  <a:srgbClr val="1B3355"/>
-                </a:solidFill>
-                <a:latin typeface="Calibri"/>
-              </a:rPr>
-              <a:t>The protections that matter to you</a:t>
-            </a:r>
-          </a:p>
-          <a:p>
-            <a:pPr algn="l">
-              <a:spcBef>
-                <a:spcPts val="400"/>
-              </a:spcBef>
-            </a:pPr>
-            <a:r>
-              <a:rPr sz="1350">
-                <a:solidFill>
-                  <a:srgbClr val="5A5A5A"/>
-                </a:solidFill>
-                <a:latin typeface="Calibri"/>
-              </a:rPr>
-              <a:t>• A2: consideration only to shareholder bodies, pro rata — the draft's 40% to one individual (zero to other WBI shareholders) becomes impossible.
-• B4/B5: any Stage-2 deal carries every shareholder through as one block at one ratio.
-• A1: if Eyesel's real revenue departs &gt;15% from $8.0M, equalisation is mandatory.</a:t>
-            </a:r>
-          </a:p>
-        </p:txBody>
-      </p:sp>
-    </p:spTree>
-  </p:cSld>
-  <p:clrMapOvr>
-    <a:masterClrMapping/>
-  </p:clrMapOvr>
-</p:sld>
-</file>
-
 <file path=ppt/slides/slide14.xml><?xml version="1.0" encoding="utf-8"?>
 <p:sld xmlns:a="http://schemas.openxmlformats.org/drawingml/2006/main" xmlns:p="http://schemas.openxmlformats.org/presentationml/2006/main" xmlns:r="http://schemas.openxmlformats.org/officeDocument/2006/relationships">
   <p:cSld>
@@ -7396,7 +7239,7 @@
                 </a:solidFill>
                 <a:latin typeface="Calibri"/>
               </a:rPr>
-              <a:t>The price test on First Vital</a:t>
+              <a:t>What this means for WBI shareholders</a:t>
             </a:r>
           </a:p>
         </p:txBody>
@@ -7435,7 +7278,7 @@
                 </a:solidFill>
                 <a:latin typeface="Calibri"/>
               </a:rPr>
-              <a:t>What the draft's percentages imply — and how to check them</a:t>
+              <a:t>Your 49% of GenApep, traced through both routes</a:t>
             </a:r>
           </a:p>
         </p:txBody>
@@ -7475,6 +7318,809 @@
                 <a:latin typeface="Calibri"/>
               </a:rPr>
               <a:t>14</a:t>
+            </a:r>
+          </a:p>
+        </p:txBody>
+      </p:sp>
+      <p:sp>
+        <p:nvSpPr>
+          <p:cNvPr id="7" name="Rounded Rectangle 6"/>
+          <p:cNvSpPr/>
+          <p:nvPr/>
+        </p:nvSpPr>
+        <p:spPr>
+          <a:xfrm>
+            <a:off x="640080" y="1554480"/>
+            <a:ext cx="2606040" cy="1965960"/>
+          </a:xfrm>
+          <a:prstGeom prst="roundRect">
+            <a:avLst/>
+          </a:prstGeom>
+          <a:solidFill>
+            <a:srgbClr val="2E86C1"/>
+          </a:solidFill>
+          <a:ln>
+            <a:noFill/>
+          </a:ln>
+        </p:spPr>
+        <p:style>
+          <a:lnRef idx="1">
+            <a:schemeClr val="accent1"/>
+          </a:lnRef>
+          <a:fillRef idx="3">
+            <a:schemeClr val="accent1"/>
+          </a:fillRef>
+          <a:effectRef idx="2">
+            <a:schemeClr val="accent1"/>
+          </a:effectRef>
+          <a:fontRef idx="minor">
+            <a:schemeClr val="lt1"/>
+          </a:fontRef>
+        </p:style>
+        <p:txBody>
+          <a:bodyPr rtlCol="0" anchor="ctr" wrap="square" lIns="76200" rIns="76200" tIns="38100" bIns="38100"/>
+          <a:lstStyle/>
+          <a:p>
+            <a:pPr algn="ctr"/>
+            <a:r>
+              <a:rPr sz="1400" b="1">
+                <a:solidFill>
+                  <a:srgbClr val="CFDDEA"/>
+                </a:solidFill>
+                <a:latin typeface="Calibri"/>
+              </a:rPr>
+              <a:t>Today</a:t>
+            </a:r>
+          </a:p>
+          <a:p>
+            <a:pPr algn="ctr"/>
+            <a:r>
+              <a:rPr sz="3000" b="1">
+                <a:solidFill>
+                  <a:srgbClr val="FFFFFF"/>
+                </a:solidFill>
+                <a:latin typeface="Calibri"/>
+              </a:rPr>
+              <a:t>49%</a:t>
+            </a:r>
+          </a:p>
+          <a:p>
+            <a:pPr algn="ctr"/>
+            <a:r>
+              <a:rPr sz="1150" b="0">
+                <a:solidFill>
+                  <a:srgbClr val="FFFFFF"/>
+                </a:solidFill>
+                <a:latin typeface="Calibri"/>
+              </a:rPr>
+              <a:t>of GenApep · ≈ $17.2M at $35M mid</a:t>
+            </a:r>
+          </a:p>
+        </p:txBody>
+      </p:sp>
+      <p:sp>
+        <p:nvSpPr>
+          <p:cNvPr id="8" name="Right Arrow 7"/>
+          <p:cNvSpPr/>
+          <p:nvPr/>
+        </p:nvSpPr>
+        <p:spPr>
+          <a:xfrm>
+            <a:off x="3264408" y="2331720"/>
+            <a:ext cx="182880" cy="411480"/>
+          </a:xfrm>
+          <a:prstGeom prst="rightArrow">
+            <a:avLst/>
+          </a:prstGeom>
+          <a:solidFill>
+            <a:srgbClr val="5A5A5A"/>
+          </a:solidFill>
+          <a:ln>
+            <a:noFill/>
+          </a:ln>
+          <a:effectLst/>
+        </p:spPr>
+        <p:style>
+          <a:lnRef idx="1">
+            <a:schemeClr val="accent1"/>
+          </a:lnRef>
+          <a:fillRef idx="3">
+            <a:schemeClr val="accent1"/>
+          </a:fillRef>
+          <a:effectRef idx="2">
+            <a:schemeClr val="accent1"/>
+          </a:effectRef>
+          <a:fontRef idx="minor">
+            <a:schemeClr val="lt1"/>
+          </a:fontRef>
+        </p:style>
+        <p:txBody>
+          <a:bodyPr rtlCol="0" anchor="ctr"/>
+          <a:lstStyle/>
+          <a:p>
+            <a:pPr algn="ctr"/>
+          </a:p>
+        </p:txBody>
+      </p:sp>
+      <p:sp>
+        <p:nvSpPr>
+          <p:cNvPr id="9" name="Rounded Rectangle 8"/>
+          <p:cNvSpPr/>
+          <p:nvPr/>
+        </p:nvSpPr>
+        <p:spPr>
+          <a:xfrm>
+            <a:off x="3456432" y="1554480"/>
+            <a:ext cx="2606040" cy="1965960"/>
+          </a:xfrm>
+          <a:prstGeom prst="roundRect">
+            <a:avLst/>
+          </a:prstGeom>
+          <a:solidFill>
+            <a:srgbClr val="1AA19C"/>
+          </a:solidFill>
+          <a:ln>
+            <a:noFill/>
+          </a:ln>
+        </p:spPr>
+        <p:style>
+          <a:lnRef idx="1">
+            <a:schemeClr val="accent1"/>
+          </a:lnRef>
+          <a:fillRef idx="3">
+            <a:schemeClr val="accent1"/>
+          </a:fillRef>
+          <a:effectRef idx="2">
+            <a:schemeClr val="accent1"/>
+          </a:effectRef>
+          <a:fontRef idx="minor">
+            <a:schemeClr val="lt1"/>
+          </a:fontRef>
+        </p:style>
+        <p:txBody>
+          <a:bodyPr rtlCol="0" anchor="ctr" wrap="square" lIns="76200" rIns="76200" tIns="38100" bIns="38100"/>
+          <a:lstStyle/>
+          <a:p>
+            <a:pPr algn="ctr"/>
+            <a:r>
+              <a:rPr sz="1400" b="1">
+                <a:solidFill>
+                  <a:srgbClr val="CFDDEA"/>
+                </a:solidFill>
+                <a:latin typeface="Calibri"/>
+              </a:rPr>
+              <a:t>After pool (7.5%)</a:t>
+            </a:r>
+          </a:p>
+          <a:p>
+            <a:pPr algn="ctr"/>
+            <a:r>
+              <a:rPr sz="3000" b="1">
+                <a:solidFill>
+                  <a:srgbClr val="FFFFFF"/>
+                </a:solidFill>
+                <a:latin typeface="Calibri"/>
+              </a:rPr>
+              <a:t>45.3%</a:t>
+            </a:r>
+          </a:p>
+          <a:p>
+            <a:pPr algn="ctr"/>
+            <a:r>
+              <a:rPr sz="1150" b="0">
+                <a:solidFill>
+                  <a:srgbClr val="FFFFFF"/>
+                </a:solidFill>
+                <a:latin typeface="Calibri"/>
+              </a:rPr>
+              <a:t>≈ $15.9M — before technology credit</a:t>
+            </a:r>
+          </a:p>
+        </p:txBody>
+      </p:sp>
+      <p:sp>
+        <p:nvSpPr>
+          <p:cNvPr id="10" name="Right Arrow 9"/>
+          <p:cNvSpPr/>
+          <p:nvPr/>
+        </p:nvSpPr>
+        <p:spPr>
+          <a:xfrm>
+            <a:off x="6080760" y="2331720"/>
+            <a:ext cx="182880" cy="411480"/>
+          </a:xfrm>
+          <a:prstGeom prst="rightArrow">
+            <a:avLst/>
+          </a:prstGeom>
+          <a:solidFill>
+            <a:srgbClr val="5A5A5A"/>
+          </a:solidFill>
+          <a:ln>
+            <a:noFill/>
+          </a:ln>
+          <a:effectLst/>
+        </p:spPr>
+        <p:style>
+          <a:lnRef idx="1">
+            <a:schemeClr val="accent1"/>
+          </a:lnRef>
+          <a:fillRef idx="3">
+            <a:schemeClr val="accent1"/>
+          </a:fillRef>
+          <a:effectRef idx="2">
+            <a:schemeClr val="accent1"/>
+          </a:effectRef>
+          <a:fontRef idx="minor">
+            <a:schemeClr val="lt1"/>
+          </a:fontRef>
+        </p:style>
+        <p:txBody>
+          <a:bodyPr rtlCol="0" anchor="ctr"/>
+          <a:lstStyle/>
+          <a:p>
+            <a:pPr algn="ctr"/>
+          </a:p>
+        </p:txBody>
+      </p:sp>
+      <p:sp>
+        <p:nvSpPr>
+          <p:cNvPr id="11" name="Rounded Rectangle 10"/>
+          <p:cNvSpPr/>
+          <p:nvPr/>
+        </p:nvSpPr>
+        <p:spPr>
+          <a:xfrm>
+            <a:off x="6272784" y="1554480"/>
+            <a:ext cx="2606040" cy="1965960"/>
+          </a:xfrm>
+          <a:prstGeom prst="roundRect">
+            <a:avLst/>
+          </a:prstGeom>
+          <a:solidFill>
+            <a:srgbClr val="E09E2B"/>
+          </a:solidFill>
+          <a:ln>
+            <a:noFill/>
+          </a:ln>
+        </p:spPr>
+        <p:style>
+          <a:lnRef idx="1">
+            <a:schemeClr val="accent1"/>
+          </a:lnRef>
+          <a:fillRef idx="3">
+            <a:schemeClr val="accent1"/>
+          </a:fillRef>
+          <a:effectRef idx="2">
+            <a:schemeClr val="accent1"/>
+          </a:effectRef>
+          <a:fontRef idx="minor">
+            <a:schemeClr val="lt1"/>
+          </a:fontRef>
+        </p:style>
+        <p:txBody>
+          <a:bodyPr rtlCol="0" anchor="ctr" wrap="square" lIns="76200" rIns="76200" tIns="38100" bIns="38100"/>
+          <a:lstStyle/>
+          <a:p>
+            <a:pPr algn="ctr"/>
+            <a:r>
+              <a:rPr sz="1400" b="1">
+                <a:solidFill>
+                  <a:srgbClr val="FFFFFF"/>
+                </a:solidFill>
+                <a:latin typeface="Calibri"/>
+              </a:rPr>
+              <a:t>Route B (FVH $10M)</a:t>
+            </a:r>
+          </a:p>
+          <a:p>
+            <a:pPr algn="ctr"/>
+            <a:r>
+              <a:rPr sz="3000" b="1">
+                <a:solidFill>
+                  <a:srgbClr val="FFFFFF"/>
+                </a:solidFill>
+                <a:latin typeface="Calibri"/>
+              </a:rPr>
+              <a:t>35.3%</a:t>
+            </a:r>
+          </a:p>
+          <a:p>
+            <a:pPr algn="ctr"/>
+            <a:r>
+              <a:rPr sz="1150" b="0">
+                <a:solidFill>
+                  <a:srgbClr val="FFFFFF"/>
+                </a:solidFill>
+                <a:latin typeface="Calibri"/>
+              </a:rPr>
+              <a:t>of the LISTED company · $28–35M if market values group at $80–100M</a:t>
+            </a:r>
+          </a:p>
+        </p:txBody>
+      </p:sp>
+      <p:sp>
+        <p:nvSpPr>
+          <p:cNvPr id="12" name="Right Arrow 11"/>
+          <p:cNvSpPr/>
+          <p:nvPr/>
+        </p:nvSpPr>
+        <p:spPr>
+          <a:xfrm>
+            <a:off x="8897112" y="2331720"/>
+            <a:ext cx="182880" cy="411480"/>
+          </a:xfrm>
+          <a:prstGeom prst="rightArrow">
+            <a:avLst/>
+          </a:prstGeom>
+          <a:solidFill>
+            <a:srgbClr val="5A5A5A"/>
+          </a:solidFill>
+          <a:ln>
+            <a:noFill/>
+          </a:ln>
+          <a:effectLst/>
+        </p:spPr>
+        <p:style>
+          <a:lnRef idx="1">
+            <a:schemeClr val="accent1"/>
+          </a:lnRef>
+          <a:fillRef idx="3">
+            <a:schemeClr val="accent1"/>
+          </a:fillRef>
+          <a:effectRef idx="2">
+            <a:schemeClr val="accent1"/>
+          </a:effectRef>
+          <a:fontRef idx="minor">
+            <a:schemeClr val="lt1"/>
+          </a:fontRef>
+        </p:style>
+        <p:txBody>
+          <a:bodyPr rtlCol="0" anchor="ctr"/>
+          <a:lstStyle/>
+          <a:p>
+            <a:pPr algn="ctr"/>
+          </a:p>
+        </p:txBody>
+      </p:sp>
+      <p:sp>
+        <p:nvSpPr>
+          <p:cNvPr id="13" name="Rounded Rectangle 12"/>
+          <p:cNvSpPr/>
+          <p:nvPr/>
+        </p:nvSpPr>
+        <p:spPr>
+          <a:xfrm>
+            <a:off x="9089136" y="1554480"/>
+            <a:ext cx="2606040" cy="1965960"/>
+          </a:xfrm>
+          <a:prstGeom prst="roundRect">
+            <a:avLst/>
+          </a:prstGeom>
+          <a:solidFill>
+            <a:srgbClr val="1B3355"/>
+          </a:solidFill>
+          <a:ln>
+            <a:noFill/>
+          </a:ln>
+        </p:spPr>
+        <p:style>
+          <a:lnRef idx="1">
+            <a:schemeClr val="accent1"/>
+          </a:lnRef>
+          <a:fillRef idx="3">
+            <a:schemeClr val="accent1"/>
+          </a:fillRef>
+          <a:effectRef idx="2">
+            <a:schemeClr val="accent1"/>
+          </a:effectRef>
+          <a:fontRef idx="minor">
+            <a:schemeClr val="lt1"/>
+          </a:fontRef>
+        </p:style>
+        <p:txBody>
+          <a:bodyPr rtlCol="0" anchor="ctr" wrap="square" lIns="76200" rIns="76200" tIns="38100" bIns="38100"/>
+          <a:lstStyle/>
+          <a:p>
+            <a:pPr algn="ctr"/>
+            <a:r>
+              <a:rPr sz="1400" b="1">
+                <a:solidFill>
+                  <a:srgbClr val="CFDDEA"/>
+                </a:solidFill>
+                <a:latin typeface="Calibri"/>
+              </a:rPr>
+              <a:t>Route A post-IPO</a:t>
+            </a:r>
+          </a:p>
+          <a:p>
+            <a:pPr algn="ctr"/>
+            <a:r>
+              <a:rPr sz="3000" b="1">
+                <a:solidFill>
+                  <a:srgbClr val="FFFFFF"/>
+                </a:solidFill>
+                <a:latin typeface="Calibri"/>
+              </a:rPr>
+              <a:t>36.3%</a:t>
+            </a:r>
+          </a:p>
+          <a:p>
+            <a:pPr algn="ctr"/>
+            <a:r>
+              <a:rPr sz="1150" b="0">
+                <a:solidFill>
+                  <a:srgbClr val="FFFFFF"/>
+                </a:solidFill>
+                <a:latin typeface="Calibri"/>
+              </a:rPr>
+              <a:t>≈ $36.3M at $80M pre + $20M raise (workbook)</a:t>
+            </a:r>
+          </a:p>
+        </p:txBody>
+      </p:sp>
+      <p:sp>
+        <p:nvSpPr>
+          <p:cNvPr id="14" name="Rounded Rectangle 13"/>
+          <p:cNvSpPr/>
+          <p:nvPr/>
+        </p:nvSpPr>
+        <p:spPr>
+          <a:xfrm>
+            <a:off x="640080" y="3794760"/>
+            <a:ext cx="5394960" cy="2331720"/>
+          </a:xfrm>
+          <a:prstGeom prst="roundRect">
+            <a:avLst/>
+          </a:prstGeom>
+          <a:solidFill>
+            <a:srgbClr val="FFFFFF"/>
+          </a:solidFill>
+          <a:ln w="19050">
+            <a:solidFill>
+              <a:srgbClr val="2E86C1"/>
+            </a:solidFill>
+          </a:ln>
+        </p:spPr>
+        <p:style>
+          <a:lnRef idx="1">
+            <a:schemeClr val="accent1"/>
+          </a:lnRef>
+          <a:fillRef idx="3">
+            <a:schemeClr val="accent1"/>
+          </a:fillRef>
+          <a:effectRef idx="2">
+            <a:schemeClr val="accent1"/>
+          </a:effectRef>
+          <a:fontRef idx="minor">
+            <a:schemeClr val="lt1"/>
+          </a:fontRef>
+        </p:style>
+        <p:txBody>
+          <a:bodyPr rtlCol="0" anchor="t" wrap="square" lIns="127000" rIns="127000" tIns="101600"/>
+          <a:lstStyle/>
+          <a:p>
+            <a:pPr algn="l"/>
+            <a:r>
+              <a:rPr sz="1700" b="1">
+                <a:solidFill>
+                  <a:srgbClr val="1B3355"/>
+                </a:solidFill>
+                <a:latin typeface="Calibri"/>
+              </a:rPr>
+              <a:t>Where WBI's value comes from</a:t>
+            </a:r>
+          </a:p>
+          <a:p>
+            <a:pPr algn="l">
+              <a:spcBef>
+                <a:spcPts val="400"/>
+              </a:spcBef>
+            </a:pPr>
+            <a:r>
+              <a:rPr sz="1350">
+                <a:solidFill>
+                  <a:srgbClr val="5A5A5A"/>
+                </a:solidFill>
+                <a:latin typeface="Calibri"/>
+              </a:rPr>
+              <a:t>• MM Studio — WBI's growth engine: $2.9M → $36.3M by 2030, the plan's biggest swing factor.
+• WBI core exports: $4.69M in 2026, +20%/yr, NTS-certified FY2025 base.
+• Technology upside (AI.pep, DPW licence) accrues inside GenApep — you participate via the block.</a:t>
+            </a:r>
+          </a:p>
+        </p:txBody>
+      </p:sp>
+      <p:sp>
+        <p:nvSpPr>
+          <p:cNvPr id="15" name="Rounded Rectangle 14"/>
+          <p:cNvSpPr/>
+          <p:nvPr/>
+        </p:nvSpPr>
+        <p:spPr>
+          <a:xfrm>
+            <a:off x="6263640" y="3794760"/>
+            <a:ext cx="5303520" cy="2331720"/>
+          </a:xfrm>
+          <a:prstGeom prst="roundRect">
+            <a:avLst/>
+          </a:prstGeom>
+          <a:solidFill>
+            <a:srgbClr val="FFFFFF"/>
+          </a:solidFill>
+          <a:ln w="19050">
+            <a:solidFill>
+              <a:srgbClr val="C0392B"/>
+            </a:solidFill>
+          </a:ln>
+        </p:spPr>
+        <p:style>
+          <a:lnRef idx="1">
+            <a:schemeClr val="accent1"/>
+          </a:lnRef>
+          <a:fillRef idx="3">
+            <a:schemeClr val="accent1"/>
+          </a:fillRef>
+          <a:effectRef idx="2">
+            <a:schemeClr val="accent1"/>
+          </a:effectRef>
+          <a:fontRef idx="minor">
+            <a:schemeClr val="lt1"/>
+          </a:fontRef>
+        </p:style>
+        <p:txBody>
+          <a:bodyPr rtlCol="0" anchor="t" wrap="square" lIns="127000" rIns="127000" tIns="101600"/>
+          <a:lstStyle/>
+          <a:p>
+            <a:pPr algn="l"/>
+            <a:r>
+              <a:rPr sz="1700" b="1">
+                <a:solidFill>
+                  <a:srgbClr val="1B3355"/>
+                </a:solidFill>
+                <a:latin typeface="Calibri"/>
+              </a:rPr>
+              <a:t>The protections that matter to you</a:t>
+            </a:r>
+          </a:p>
+          <a:p>
+            <a:pPr algn="l">
+              <a:spcBef>
+                <a:spcPts val="400"/>
+              </a:spcBef>
+            </a:pPr>
+            <a:r>
+              <a:rPr sz="1350">
+                <a:solidFill>
+                  <a:srgbClr val="5A5A5A"/>
+                </a:solidFill>
+                <a:latin typeface="Calibri"/>
+              </a:rPr>
+              <a:t>• A2: consideration only to shareholder bodies, pro rata — the draft's 40% to one individual (zero to other WBI shareholders) becomes impossible.
+• B4/B5: any Stage-2 deal carries every shareholder through as one block at one ratio.
+• A1: if Eyesel's real revenue departs &gt;15% from $8.0M, equalisation is mandatory.</a:t>
+            </a:r>
+          </a:p>
+        </p:txBody>
+      </p:sp>
+    </p:spTree>
+  </p:cSld>
+  <p:clrMapOvr>
+    <a:masterClrMapping/>
+  </p:clrMapOvr>
+</p:sld>
+</file>
+
+<file path=ppt/slides/slide15.xml><?xml version="1.0" encoding="utf-8"?>
+<p:sld xmlns:a="http://schemas.openxmlformats.org/drawingml/2006/main" xmlns:p="http://schemas.openxmlformats.org/presentationml/2006/main" xmlns:r="http://schemas.openxmlformats.org/officeDocument/2006/relationships">
+  <p:cSld>
+    <p:spTree>
+      <p:nvGrpSpPr>
+        <p:cNvPr id="1" name=""/>
+        <p:cNvGrpSpPr/>
+        <p:nvPr/>
+      </p:nvGrpSpPr>
+      <p:grpSpPr/>
+      <p:sp>
+        <p:nvSpPr>
+          <p:cNvPr id="2" name="Rectangle 1"/>
+          <p:cNvSpPr/>
+          <p:nvPr/>
+        </p:nvSpPr>
+        <p:spPr>
+          <a:xfrm>
+            <a:off x="0" y="0"/>
+            <a:ext cx="12191695" cy="1097280"/>
+          </a:xfrm>
+          <a:prstGeom prst="rect">
+            <a:avLst/>
+          </a:prstGeom>
+          <a:solidFill>
+            <a:srgbClr val="1B3355"/>
+          </a:solidFill>
+          <a:ln>
+            <a:noFill/>
+          </a:ln>
+          <a:effectLst/>
+        </p:spPr>
+        <p:style>
+          <a:lnRef idx="1">
+            <a:schemeClr val="accent1"/>
+          </a:lnRef>
+          <a:fillRef idx="3">
+            <a:schemeClr val="accent1"/>
+          </a:fillRef>
+          <a:effectRef idx="2">
+            <a:schemeClr val="accent1"/>
+          </a:effectRef>
+          <a:fontRef idx="minor">
+            <a:schemeClr val="lt1"/>
+          </a:fontRef>
+        </p:style>
+        <p:txBody>
+          <a:bodyPr rtlCol="0" anchor="ctr"/>
+          <a:lstStyle/>
+          <a:p>
+            <a:pPr algn="ctr"/>
+          </a:p>
+        </p:txBody>
+      </p:sp>
+      <p:sp>
+        <p:nvSpPr>
+          <p:cNvPr id="3" name="Rectangle 2"/>
+          <p:cNvSpPr/>
+          <p:nvPr/>
+        </p:nvSpPr>
+        <p:spPr>
+          <a:xfrm>
+            <a:off x="502920" y="310896"/>
+            <a:ext cx="128016" cy="475488"/>
+          </a:xfrm>
+          <a:prstGeom prst="rect">
+            <a:avLst/>
+          </a:prstGeom>
+          <a:solidFill>
+            <a:srgbClr val="2E86C1"/>
+          </a:solidFill>
+          <a:ln>
+            <a:noFill/>
+          </a:ln>
+          <a:effectLst/>
+        </p:spPr>
+        <p:style>
+          <a:lnRef idx="1">
+            <a:schemeClr val="accent1"/>
+          </a:lnRef>
+          <a:fillRef idx="3">
+            <a:schemeClr val="accent1"/>
+          </a:fillRef>
+          <a:effectRef idx="2">
+            <a:schemeClr val="accent1"/>
+          </a:effectRef>
+          <a:fontRef idx="minor">
+            <a:schemeClr val="lt1"/>
+          </a:fontRef>
+        </p:style>
+        <p:txBody>
+          <a:bodyPr rtlCol="0" anchor="ctr"/>
+          <a:lstStyle/>
+          <a:p>
+            <a:pPr algn="ctr"/>
+          </a:p>
+        </p:txBody>
+      </p:sp>
+      <p:sp>
+        <p:nvSpPr>
+          <p:cNvPr id="4" name="TextBox 3"/>
+          <p:cNvSpPr txBox="1"/>
+          <p:nvPr/>
+        </p:nvSpPr>
+        <p:spPr>
+          <a:xfrm>
+            <a:off x="777240" y="164592"/>
+            <a:ext cx="10607040" cy="822960"/>
+          </a:xfrm>
+          <a:prstGeom prst="rect">
+            <a:avLst/>
+          </a:prstGeom>
+          <a:noFill/>
+        </p:spPr>
+        <p:txBody>
+          <a:bodyPr wrap="square" anchor="ctr">
+            <a:spAutoFit/>
+          </a:bodyPr>
+          <a:lstStyle/>
+          <a:p>
+            <a:pPr algn="l">
+              <a:spcAft>
+                <a:spcPts val="400"/>
+              </a:spcAft>
+            </a:pPr>
+            <a:r>
+              <a:rPr sz="2700" b="1">
+                <a:solidFill>
+                  <a:srgbClr val="FFFFFF"/>
+                </a:solidFill>
+                <a:latin typeface="Calibri"/>
+              </a:rPr>
+              <a:t>The price test on First Vital</a:t>
+            </a:r>
+          </a:p>
+        </p:txBody>
+      </p:sp>
+      <p:sp>
+        <p:nvSpPr>
+          <p:cNvPr id="5" name="TextBox 4"/>
+          <p:cNvSpPr txBox="1"/>
+          <p:nvPr/>
+        </p:nvSpPr>
+        <p:spPr>
+          <a:xfrm>
+            <a:off x="795528" y="786384"/>
+            <a:ext cx="10607040" cy="274320"/>
+          </a:xfrm>
+          <a:prstGeom prst="rect">
+            <a:avLst/>
+          </a:prstGeom>
+          <a:noFill/>
+        </p:spPr>
+        <p:txBody>
+          <a:bodyPr wrap="square" anchor="t">
+            <a:spAutoFit/>
+          </a:bodyPr>
+          <a:lstStyle/>
+          <a:p>
+            <a:pPr algn="l">
+              <a:spcAft>
+                <a:spcPts val="400"/>
+              </a:spcAft>
+            </a:pPr>
+            <a:r>
+              <a:rPr sz="1400" b="0">
+                <a:solidFill>
+                  <a:srgbClr val="CFDDEA"/>
+                </a:solidFill>
+                <a:latin typeface="Calibri"/>
+              </a:rPr>
+              <a:t>What the draft's percentages imply — and how to check them</a:t>
+            </a:r>
+          </a:p>
+        </p:txBody>
+      </p:sp>
+      <p:sp>
+        <p:nvSpPr>
+          <p:cNvPr id="6" name="TextBox 5"/>
+          <p:cNvSpPr txBox="1"/>
+          <p:nvPr/>
+        </p:nvSpPr>
+        <p:spPr>
+          <a:xfrm>
+            <a:off x="11338560" y="6437376"/>
+            <a:ext cx="731520" cy="320040"/>
+          </a:xfrm>
+          <a:prstGeom prst="rect">
+            <a:avLst/>
+          </a:prstGeom>
+          <a:noFill/>
+        </p:spPr>
+        <p:txBody>
+          <a:bodyPr wrap="square" anchor="t">
+            <a:spAutoFit/>
+          </a:bodyPr>
+          <a:lstStyle/>
+          <a:p>
+            <a:pPr algn="r">
+              <a:spcAft>
+                <a:spcPts val="400"/>
+              </a:spcAft>
+            </a:pPr>
+            <a:r>
+              <a:rPr sz="1200" b="0">
+                <a:solidFill>
+                  <a:srgbClr val="5A5A5A"/>
+                </a:solidFill>
+                <a:latin typeface="Calibri"/>
+              </a:rPr>
+              <a:t>15</a:t>
             </a:r>
           </a:p>
         </p:txBody>
@@ -8116,382 +8762,6 @@
 </p:sld>
 </file>
 
-<file path=ppt/slides/slide15.xml><?xml version="1.0" encoding="utf-8"?>
-<p:sld xmlns:a="http://schemas.openxmlformats.org/drawingml/2006/main" xmlns:p="http://schemas.openxmlformats.org/presentationml/2006/main" xmlns:r="http://schemas.openxmlformats.org/officeDocument/2006/relationships">
-  <p:cSld>
-    <p:spTree>
-      <p:nvGrpSpPr>
-        <p:cNvPr id="1" name=""/>
-        <p:cNvGrpSpPr/>
-        <p:nvPr/>
-      </p:nvGrpSpPr>
-      <p:grpSpPr/>
-      <p:sp>
-        <p:nvSpPr>
-          <p:cNvPr id="2" name="Rectangle 1"/>
-          <p:cNvSpPr/>
-          <p:nvPr/>
-        </p:nvSpPr>
-        <p:spPr>
-          <a:xfrm>
-            <a:off x="0" y="0"/>
-            <a:ext cx="12191695" cy="1097280"/>
-          </a:xfrm>
-          <a:prstGeom prst="rect">
-            <a:avLst/>
-          </a:prstGeom>
-          <a:solidFill>
-            <a:srgbClr val="1B3355"/>
-          </a:solidFill>
-          <a:ln>
-            <a:noFill/>
-          </a:ln>
-          <a:effectLst/>
-        </p:spPr>
-        <p:style>
-          <a:lnRef idx="1">
-            <a:schemeClr val="accent1"/>
-          </a:lnRef>
-          <a:fillRef idx="3">
-            <a:schemeClr val="accent1"/>
-          </a:fillRef>
-          <a:effectRef idx="2">
-            <a:schemeClr val="accent1"/>
-          </a:effectRef>
-          <a:fontRef idx="minor">
-            <a:schemeClr val="lt1"/>
-          </a:fontRef>
-        </p:style>
-        <p:txBody>
-          <a:bodyPr rtlCol="0" anchor="ctr"/>
-          <a:lstStyle/>
-          <a:p>
-            <a:pPr algn="ctr"/>
-          </a:p>
-        </p:txBody>
-      </p:sp>
-      <p:sp>
-        <p:nvSpPr>
-          <p:cNvPr id="3" name="Rectangle 2"/>
-          <p:cNvSpPr/>
-          <p:nvPr/>
-        </p:nvSpPr>
-        <p:spPr>
-          <a:xfrm>
-            <a:off x="502920" y="310896"/>
-            <a:ext cx="128016" cy="475488"/>
-          </a:xfrm>
-          <a:prstGeom prst="rect">
-            <a:avLst/>
-          </a:prstGeom>
-          <a:solidFill>
-            <a:srgbClr val="2E86C1"/>
-          </a:solidFill>
-          <a:ln>
-            <a:noFill/>
-          </a:ln>
-          <a:effectLst/>
-        </p:spPr>
-        <p:style>
-          <a:lnRef idx="1">
-            <a:schemeClr val="accent1"/>
-          </a:lnRef>
-          <a:fillRef idx="3">
-            <a:schemeClr val="accent1"/>
-          </a:fillRef>
-          <a:effectRef idx="2">
-            <a:schemeClr val="accent1"/>
-          </a:effectRef>
-          <a:fontRef idx="minor">
-            <a:schemeClr val="lt1"/>
-          </a:fontRef>
-        </p:style>
-        <p:txBody>
-          <a:bodyPr rtlCol="0" anchor="ctr"/>
-          <a:lstStyle/>
-          <a:p>
-            <a:pPr algn="ctr"/>
-          </a:p>
-        </p:txBody>
-      </p:sp>
-      <p:sp>
-        <p:nvSpPr>
-          <p:cNvPr id="4" name="TextBox 3"/>
-          <p:cNvSpPr txBox="1"/>
-          <p:nvPr/>
-        </p:nvSpPr>
-        <p:spPr>
-          <a:xfrm>
-            <a:off x="777240" y="164592"/>
-            <a:ext cx="10607040" cy="822960"/>
-          </a:xfrm>
-          <a:prstGeom prst="rect">
-            <a:avLst/>
-          </a:prstGeom>
-          <a:noFill/>
-        </p:spPr>
-        <p:txBody>
-          <a:bodyPr wrap="square" anchor="ctr">
-            <a:spAutoFit/>
-          </a:bodyPr>
-          <a:lstStyle/>
-          <a:p>
-            <a:pPr algn="l">
-              <a:spcAft>
-                <a:spcPts val="400"/>
-              </a:spcAft>
-            </a:pPr>
-            <a:r>
-              <a:rPr sz="2700" b="1">
-                <a:solidFill>
-                  <a:srgbClr val="FFFFFF"/>
-                </a:solidFill>
-                <a:latin typeface="Calibri"/>
-              </a:rPr>
-              <a:t>Protections already drafted</a:t>
-            </a:r>
-          </a:p>
-        </p:txBody>
-      </p:sp>
-      <p:sp>
-        <p:nvSpPr>
-          <p:cNvPr id="5" name="TextBox 4"/>
-          <p:cNvSpPr txBox="1"/>
-          <p:nvPr/>
-        </p:nvSpPr>
-        <p:spPr>
-          <a:xfrm>
-            <a:off x="795528" y="786384"/>
-            <a:ext cx="10607040" cy="274320"/>
-          </a:xfrm>
-          <a:prstGeom prst="rect">
-            <a:avLst/>
-          </a:prstGeom>
-          <a:noFill/>
-        </p:spPr>
-        <p:txBody>
-          <a:bodyPr wrap="square" anchor="t">
-            <a:spAutoFit/>
-          </a:bodyPr>
-          <a:lstStyle/>
-          <a:p>
-            <a:pPr algn="l">
-              <a:spcAft>
-                <a:spcPts val="400"/>
-              </a:spcAft>
-            </a:pPr>
-            <a:r>
-              <a:rPr sz="1400" b="0">
-                <a:solidFill>
-                  <a:srgbClr val="CFDDEA"/>
-                </a:solidFill>
-                <a:latin typeface="Calibri"/>
-              </a:rPr>
-              <a:t>Sign Amendment No. 1 now; Addendum A when Route B is live</a:t>
-            </a:r>
-          </a:p>
-        </p:txBody>
-      </p:sp>
-      <p:sp>
-        <p:nvSpPr>
-          <p:cNvPr id="6" name="TextBox 5"/>
-          <p:cNvSpPr txBox="1"/>
-          <p:nvPr/>
-        </p:nvSpPr>
-        <p:spPr>
-          <a:xfrm>
-            <a:off x="11338560" y="6437376"/>
-            <a:ext cx="731520" cy="320040"/>
-          </a:xfrm>
-          <a:prstGeom prst="rect">
-            <a:avLst/>
-          </a:prstGeom>
-          <a:noFill/>
-        </p:spPr>
-        <p:txBody>
-          <a:bodyPr wrap="square" anchor="t">
-            <a:spAutoFit/>
-          </a:bodyPr>
-          <a:lstStyle/>
-          <a:p>
-            <a:pPr algn="r">
-              <a:spcAft>
-                <a:spcPts val="400"/>
-              </a:spcAft>
-            </a:pPr>
-            <a:r>
-              <a:rPr sz="1200" b="0">
-                <a:solidFill>
-                  <a:srgbClr val="5A5A5A"/>
-                </a:solidFill>
-                <a:latin typeface="Calibri"/>
-              </a:rPr>
-              <a:t>15</a:t>
-            </a:r>
-          </a:p>
-        </p:txBody>
-      </p:sp>
-      <p:sp>
-        <p:nvSpPr>
-          <p:cNvPr id="7" name="Rounded Rectangle 6"/>
-          <p:cNvSpPr/>
-          <p:nvPr/>
-        </p:nvSpPr>
-        <p:spPr>
-          <a:xfrm>
-            <a:off x="640080" y="1463040"/>
-            <a:ext cx="5394960" cy="4663440"/>
-          </a:xfrm>
-          <a:prstGeom prst="roundRect">
-            <a:avLst/>
-          </a:prstGeom>
-          <a:solidFill>
-            <a:srgbClr val="FFFFFF"/>
-          </a:solidFill>
-          <a:ln w="19050">
-            <a:solidFill>
-              <a:srgbClr val="2E86C1"/>
-            </a:solidFill>
-          </a:ln>
-        </p:spPr>
-        <p:style>
-          <a:lnRef idx="1">
-            <a:schemeClr val="accent1"/>
-          </a:lnRef>
-          <a:fillRef idx="3">
-            <a:schemeClr val="accent1"/>
-          </a:fillRef>
-          <a:effectRef idx="2">
-            <a:schemeClr val="accent1"/>
-          </a:effectRef>
-          <a:fontRef idx="minor">
-            <a:schemeClr val="lt1"/>
-          </a:fontRef>
-        </p:style>
-        <p:txBody>
-          <a:bodyPr rtlCol="0" anchor="t" wrap="square" lIns="127000" rIns="127000" tIns="101600"/>
-          <a:lstStyle/>
-          <a:p>
-            <a:pPr algn="l"/>
-            <a:r>
-              <a:rPr sz="1700" b="1">
-                <a:solidFill>
-                  <a:srgbClr val="1B3355"/>
-                </a:solidFill>
-                <a:latin typeface="Calibri"/>
-              </a:rPr>
-              <a:t>Amendment No. 1 (both scenarios)</a:t>
-            </a:r>
-          </a:p>
-          <a:p>
-            <a:pPr algn="l">
-              <a:spcBef>
-                <a:spcPts val="400"/>
-              </a:spcBef>
-            </a:pPr>
-            <a:r>
-              <a:rPr sz="1350">
-                <a:solidFill>
-                  <a:srgbClr val="5A5A5A"/>
-                </a:solidFill>
-                <a:latin typeface="Calibri"/>
-              </a:rPr>
-              <a:t>A1 · Equalisation becomes MANDATORY beyond 15% variance — independent valuer decides if boards cannot.
-A2 · Consideration to shareholder bodies pro rata, never to principals.
-A3/A4 · Third-Director interests disclosed; deadlocks resolved (pool fixed at 7.5% fallback).
-A5 · Technology chain of title = condition precedent to completion.
-A6/A7 · Technology encumbrances disclosed; provenance pack before sweat-equity vesting.
-A8 · No one may present GenApep as an existing rights-holding entity before it is one.
-A9 · Open items scheduled with owners and dates.</a:t>
-            </a:r>
-          </a:p>
-        </p:txBody>
-      </p:sp>
-      <p:sp>
-        <p:nvSpPr>
-          <p:cNvPr id="8" name="Rounded Rectangle 7"/>
-          <p:cNvSpPr/>
-          <p:nvPr/>
-        </p:nvSpPr>
-        <p:spPr>
-          <a:xfrm>
-            <a:off x="6263640" y="1463040"/>
-            <a:ext cx="5303520" cy="4663440"/>
-          </a:xfrm>
-          <a:prstGeom prst="roundRect">
-            <a:avLst/>
-          </a:prstGeom>
-          <a:solidFill>
-            <a:srgbClr val="FFFFFF"/>
-          </a:solidFill>
-          <a:ln w="19050">
-            <a:solidFill>
-              <a:srgbClr val="E09E2B"/>
-            </a:solidFill>
-          </a:ln>
-        </p:spPr>
-        <p:style>
-          <a:lnRef idx="1">
-            <a:schemeClr val="accent1"/>
-          </a:lnRef>
-          <a:fillRef idx="3">
-            <a:schemeClr val="accent1"/>
-          </a:fillRef>
-          <a:effectRef idx="2">
-            <a:schemeClr val="accent1"/>
-          </a:effectRef>
-          <a:fontRef idx="minor">
-            <a:schemeClr val="lt1"/>
-          </a:fontRef>
-        </p:style>
-        <p:txBody>
-          <a:bodyPr rtlCol="0" anchor="t" wrap="square" lIns="127000" rIns="127000" tIns="101600"/>
-          <a:lstStyle/>
-          <a:p>
-            <a:pPr algn="l"/>
-            <a:r>
-              <a:rPr sz="1700" b="1">
-                <a:solidFill>
-                  <a:srgbClr val="1B3355"/>
-                </a:solidFill>
-                <a:latin typeface="Calibri"/>
-              </a:rPr>
-              <a:t>Addendum A (Route-B machinery)</a:t>
-            </a:r>
-          </a:p>
-          <a:p>
-            <a:pPr algn="l">
-              <a:spcBef>
-                <a:spcPts val="400"/>
-              </a:spcBef>
-            </a:pPr>
-            <a:r>
-              <a:rPr sz="1350">
-                <a:solidFill>
-                  <a:srgbClr val="5A5A5A"/>
-                </a:solidFill>
-                <a:latin typeface="Calibri"/>
-              </a:rPr>
-              <a:t>B1 · GenApep Korea is the ONLY permitted acquisition vehicle.
-B2 · Sweat pool carries into any new structure on equivalent terms.
-B3 · Route selection is a Reserved Matter; Route A stays the default.
-B4 · Ratio preservation: consideration strictly pro rata — binding.
-B5 · Block entry: one exchange ratio for the whole JV, never individual deals.
-B6/B11 · No unilateral negotiation; exclusivity extends to listing vehicles.
-B7 · Related-party deals need valuations, fairness opinion, disinterested approval.
-B8–B10, B12 · Verification gates, audit scoped for either route, consequences schedule.</a:t>
-            </a:r>
-          </a:p>
-        </p:txBody>
-      </p:sp>
-    </p:spTree>
-  </p:cSld>
-  <p:clrMapOvr>
-    <a:masterClrMapping/>
-  </p:clrMapOvr>
-</p:sld>
-</file>
-
 <file path=ppt/slides/slide16.xml><?xml version="1.0" encoding="utf-8"?>
 <p:sld xmlns:a="http://schemas.openxmlformats.org/drawingml/2006/main" xmlns:p="http://schemas.openxmlformats.org/presentationml/2006/main" xmlns:r="http://schemas.openxmlformats.org/officeDocument/2006/relationships">
   <p:cSld>
@@ -8624,7 +8894,7 @@
                 </a:solidFill>
                 <a:latin typeface="Calibri"/>
               </a:rPr>
-              <a:t>Timeline &amp; critical path</a:t>
+              <a:t>Protections already drafted</a:t>
             </a:r>
           </a:p>
         </p:txBody>
@@ -8663,7 +8933,7 @@
                 </a:solidFill>
                 <a:latin typeface="Calibri"/>
               </a:rPr>
-              <a:t>The audit is the clock; everything else runs in parallel</a:t>
+              <a:t>Sign Amendment No. 1 now; Addendum A when Route B is live</a:t>
             </a:r>
           </a:p>
         </p:txBody>
@@ -8703,6 +8973,382 @@
                 <a:latin typeface="Calibri"/>
               </a:rPr>
               <a:t>16</a:t>
+            </a:r>
+          </a:p>
+        </p:txBody>
+      </p:sp>
+      <p:sp>
+        <p:nvSpPr>
+          <p:cNvPr id="7" name="Rounded Rectangle 6"/>
+          <p:cNvSpPr/>
+          <p:nvPr/>
+        </p:nvSpPr>
+        <p:spPr>
+          <a:xfrm>
+            <a:off x="640080" y="1463040"/>
+            <a:ext cx="5394960" cy="4663440"/>
+          </a:xfrm>
+          <a:prstGeom prst="roundRect">
+            <a:avLst/>
+          </a:prstGeom>
+          <a:solidFill>
+            <a:srgbClr val="FFFFFF"/>
+          </a:solidFill>
+          <a:ln w="19050">
+            <a:solidFill>
+              <a:srgbClr val="2E86C1"/>
+            </a:solidFill>
+          </a:ln>
+        </p:spPr>
+        <p:style>
+          <a:lnRef idx="1">
+            <a:schemeClr val="accent1"/>
+          </a:lnRef>
+          <a:fillRef idx="3">
+            <a:schemeClr val="accent1"/>
+          </a:fillRef>
+          <a:effectRef idx="2">
+            <a:schemeClr val="accent1"/>
+          </a:effectRef>
+          <a:fontRef idx="minor">
+            <a:schemeClr val="lt1"/>
+          </a:fontRef>
+        </p:style>
+        <p:txBody>
+          <a:bodyPr rtlCol="0" anchor="t" wrap="square" lIns="127000" rIns="127000" tIns="101600"/>
+          <a:lstStyle/>
+          <a:p>
+            <a:pPr algn="l"/>
+            <a:r>
+              <a:rPr sz="1700" b="1">
+                <a:solidFill>
+                  <a:srgbClr val="1B3355"/>
+                </a:solidFill>
+                <a:latin typeface="Calibri"/>
+              </a:rPr>
+              <a:t>Amendment No. 1 (both scenarios)</a:t>
+            </a:r>
+          </a:p>
+          <a:p>
+            <a:pPr algn="l">
+              <a:spcBef>
+                <a:spcPts val="400"/>
+              </a:spcBef>
+            </a:pPr>
+            <a:r>
+              <a:rPr sz="1350">
+                <a:solidFill>
+                  <a:srgbClr val="5A5A5A"/>
+                </a:solidFill>
+                <a:latin typeface="Calibri"/>
+              </a:rPr>
+              <a:t>A1 · Equalisation becomes MANDATORY beyond 15% variance — independent valuer decides if boards cannot.
+A2 · Consideration to shareholder bodies pro rata, never to principals.
+A3/A4 · Third-Director interests disclosed; deadlocks resolved (pool fixed at 7.5% fallback).
+A5 · Technology chain of title = condition precedent to completion.
+A6/A7 · Technology encumbrances disclosed; provenance pack before sweat-equity vesting.
+A8 · No one may present GenApep as an existing rights-holding entity before it is one.
+A9 · Open items scheduled with owners and dates.</a:t>
+            </a:r>
+          </a:p>
+        </p:txBody>
+      </p:sp>
+      <p:sp>
+        <p:nvSpPr>
+          <p:cNvPr id="8" name="Rounded Rectangle 7"/>
+          <p:cNvSpPr/>
+          <p:nvPr/>
+        </p:nvSpPr>
+        <p:spPr>
+          <a:xfrm>
+            <a:off x="6263640" y="1463040"/>
+            <a:ext cx="5303520" cy="4663440"/>
+          </a:xfrm>
+          <a:prstGeom prst="roundRect">
+            <a:avLst/>
+          </a:prstGeom>
+          <a:solidFill>
+            <a:srgbClr val="FFFFFF"/>
+          </a:solidFill>
+          <a:ln w="19050">
+            <a:solidFill>
+              <a:srgbClr val="E09E2B"/>
+            </a:solidFill>
+          </a:ln>
+        </p:spPr>
+        <p:style>
+          <a:lnRef idx="1">
+            <a:schemeClr val="accent1"/>
+          </a:lnRef>
+          <a:fillRef idx="3">
+            <a:schemeClr val="accent1"/>
+          </a:fillRef>
+          <a:effectRef idx="2">
+            <a:schemeClr val="accent1"/>
+          </a:effectRef>
+          <a:fontRef idx="minor">
+            <a:schemeClr val="lt1"/>
+          </a:fontRef>
+        </p:style>
+        <p:txBody>
+          <a:bodyPr rtlCol="0" anchor="t" wrap="square" lIns="127000" rIns="127000" tIns="101600"/>
+          <a:lstStyle/>
+          <a:p>
+            <a:pPr algn="l"/>
+            <a:r>
+              <a:rPr sz="1700" b="1">
+                <a:solidFill>
+                  <a:srgbClr val="1B3355"/>
+                </a:solidFill>
+                <a:latin typeface="Calibri"/>
+              </a:rPr>
+              <a:t>Addendum A (Route-B machinery)</a:t>
+            </a:r>
+          </a:p>
+          <a:p>
+            <a:pPr algn="l">
+              <a:spcBef>
+                <a:spcPts val="400"/>
+              </a:spcBef>
+            </a:pPr>
+            <a:r>
+              <a:rPr sz="1350">
+                <a:solidFill>
+                  <a:srgbClr val="5A5A5A"/>
+                </a:solidFill>
+                <a:latin typeface="Calibri"/>
+              </a:rPr>
+              <a:t>B1 · GenApep Korea is the ONLY permitted acquisition vehicle.
+B2 · Sweat pool carries into any new structure on equivalent terms.
+B3 · Route selection is a Reserved Matter; Route A stays the default.
+B4 · Ratio preservation: consideration strictly pro rata — binding.
+B5 · Block entry: one exchange ratio for the whole JV, never individual deals.
+B6/B11 · No unilateral negotiation; exclusivity extends to listing vehicles.
+B7 · Related-party deals need valuations, fairness opinion, disinterested approval.
+B8–B10, B12 · Verification gates, audit scoped for either route, consequences schedule.</a:t>
+            </a:r>
+          </a:p>
+        </p:txBody>
+      </p:sp>
+    </p:spTree>
+  </p:cSld>
+  <p:clrMapOvr>
+    <a:masterClrMapping/>
+  </p:clrMapOvr>
+</p:sld>
+</file>
+
+<file path=ppt/slides/slide17.xml><?xml version="1.0" encoding="utf-8"?>
+<p:sld xmlns:a="http://schemas.openxmlformats.org/drawingml/2006/main" xmlns:p="http://schemas.openxmlformats.org/presentationml/2006/main" xmlns:r="http://schemas.openxmlformats.org/officeDocument/2006/relationships">
+  <p:cSld>
+    <p:spTree>
+      <p:nvGrpSpPr>
+        <p:cNvPr id="1" name=""/>
+        <p:cNvGrpSpPr/>
+        <p:nvPr/>
+      </p:nvGrpSpPr>
+      <p:grpSpPr/>
+      <p:sp>
+        <p:nvSpPr>
+          <p:cNvPr id="2" name="Rectangle 1"/>
+          <p:cNvSpPr/>
+          <p:nvPr/>
+        </p:nvSpPr>
+        <p:spPr>
+          <a:xfrm>
+            <a:off x="0" y="0"/>
+            <a:ext cx="12191695" cy="1097280"/>
+          </a:xfrm>
+          <a:prstGeom prst="rect">
+            <a:avLst/>
+          </a:prstGeom>
+          <a:solidFill>
+            <a:srgbClr val="1B3355"/>
+          </a:solidFill>
+          <a:ln>
+            <a:noFill/>
+          </a:ln>
+          <a:effectLst/>
+        </p:spPr>
+        <p:style>
+          <a:lnRef idx="1">
+            <a:schemeClr val="accent1"/>
+          </a:lnRef>
+          <a:fillRef idx="3">
+            <a:schemeClr val="accent1"/>
+          </a:fillRef>
+          <a:effectRef idx="2">
+            <a:schemeClr val="accent1"/>
+          </a:effectRef>
+          <a:fontRef idx="minor">
+            <a:schemeClr val="lt1"/>
+          </a:fontRef>
+        </p:style>
+        <p:txBody>
+          <a:bodyPr rtlCol="0" anchor="ctr"/>
+          <a:lstStyle/>
+          <a:p>
+            <a:pPr algn="ctr"/>
+          </a:p>
+        </p:txBody>
+      </p:sp>
+      <p:sp>
+        <p:nvSpPr>
+          <p:cNvPr id="3" name="Rectangle 2"/>
+          <p:cNvSpPr/>
+          <p:nvPr/>
+        </p:nvSpPr>
+        <p:spPr>
+          <a:xfrm>
+            <a:off x="502920" y="310896"/>
+            <a:ext cx="128016" cy="475488"/>
+          </a:xfrm>
+          <a:prstGeom prst="rect">
+            <a:avLst/>
+          </a:prstGeom>
+          <a:solidFill>
+            <a:srgbClr val="2E86C1"/>
+          </a:solidFill>
+          <a:ln>
+            <a:noFill/>
+          </a:ln>
+          <a:effectLst/>
+        </p:spPr>
+        <p:style>
+          <a:lnRef idx="1">
+            <a:schemeClr val="accent1"/>
+          </a:lnRef>
+          <a:fillRef idx="3">
+            <a:schemeClr val="accent1"/>
+          </a:fillRef>
+          <a:effectRef idx="2">
+            <a:schemeClr val="accent1"/>
+          </a:effectRef>
+          <a:fontRef idx="minor">
+            <a:schemeClr val="lt1"/>
+          </a:fontRef>
+        </p:style>
+        <p:txBody>
+          <a:bodyPr rtlCol="0" anchor="ctr"/>
+          <a:lstStyle/>
+          <a:p>
+            <a:pPr algn="ctr"/>
+          </a:p>
+        </p:txBody>
+      </p:sp>
+      <p:sp>
+        <p:nvSpPr>
+          <p:cNvPr id="4" name="TextBox 3"/>
+          <p:cNvSpPr txBox="1"/>
+          <p:nvPr/>
+        </p:nvSpPr>
+        <p:spPr>
+          <a:xfrm>
+            <a:off x="777240" y="164592"/>
+            <a:ext cx="10607040" cy="822960"/>
+          </a:xfrm>
+          <a:prstGeom prst="rect">
+            <a:avLst/>
+          </a:prstGeom>
+          <a:noFill/>
+        </p:spPr>
+        <p:txBody>
+          <a:bodyPr wrap="square" anchor="ctr">
+            <a:spAutoFit/>
+          </a:bodyPr>
+          <a:lstStyle/>
+          <a:p>
+            <a:pPr algn="l">
+              <a:spcAft>
+                <a:spcPts val="400"/>
+              </a:spcAft>
+            </a:pPr>
+            <a:r>
+              <a:rPr sz="2700" b="1">
+                <a:solidFill>
+                  <a:srgbClr val="FFFFFF"/>
+                </a:solidFill>
+                <a:latin typeface="Calibri"/>
+              </a:rPr>
+              <a:t>Timeline &amp; critical path</a:t>
+            </a:r>
+          </a:p>
+        </p:txBody>
+      </p:sp>
+      <p:sp>
+        <p:nvSpPr>
+          <p:cNvPr id="5" name="TextBox 4"/>
+          <p:cNvSpPr txBox="1"/>
+          <p:nvPr/>
+        </p:nvSpPr>
+        <p:spPr>
+          <a:xfrm>
+            <a:off x="795528" y="786384"/>
+            <a:ext cx="10607040" cy="274320"/>
+          </a:xfrm>
+          <a:prstGeom prst="rect">
+            <a:avLst/>
+          </a:prstGeom>
+          <a:noFill/>
+        </p:spPr>
+        <p:txBody>
+          <a:bodyPr wrap="square" anchor="t">
+            <a:spAutoFit/>
+          </a:bodyPr>
+          <a:lstStyle/>
+          <a:p>
+            <a:pPr algn="l">
+              <a:spcAft>
+                <a:spcPts val="400"/>
+              </a:spcAft>
+            </a:pPr>
+            <a:r>
+              <a:rPr sz="1400" b="0">
+                <a:solidFill>
+                  <a:srgbClr val="CFDDEA"/>
+                </a:solidFill>
+                <a:latin typeface="Calibri"/>
+              </a:rPr>
+              <a:t>The audit is the clock; everything else runs in parallel</a:t>
+            </a:r>
+          </a:p>
+        </p:txBody>
+      </p:sp>
+      <p:sp>
+        <p:nvSpPr>
+          <p:cNvPr id="6" name="TextBox 5"/>
+          <p:cNvSpPr txBox="1"/>
+          <p:nvPr/>
+        </p:nvSpPr>
+        <p:spPr>
+          <a:xfrm>
+            <a:off x="11338560" y="6437376"/>
+            <a:ext cx="731520" cy="320040"/>
+          </a:xfrm>
+          <a:prstGeom prst="rect">
+            <a:avLst/>
+          </a:prstGeom>
+          <a:noFill/>
+        </p:spPr>
+        <p:txBody>
+          <a:bodyPr wrap="square" anchor="t">
+            <a:spAutoFit/>
+          </a:bodyPr>
+          <a:lstStyle/>
+          <a:p>
+            <a:pPr algn="r">
+              <a:spcAft>
+                <a:spcPts val="400"/>
+              </a:spcAft>
+            </a:pPr>
+            <a:r>
+              <a:rPr sz="1200" b="0">
+                <a:solidFill>
+                  <a:srgbClr val="5A5A5A"/>
+                </a:solidFill>
+                <a:latin typeface="Calibri"/>
+              </a:rPr>
+              <a:t>17</a:t>
             </a:r>
           </a:p>
         </p:txBody>
@@ -9407,7 +10053,7 @@
 </p:sld>
 </file>
 
-<file path=ppt/slides/slide17.xml><?xml version="1.0" encoding="utf-8"?>
+<file path=ppt/slides/slide18.xml><?xml version="1.0" encoding="utf-8"?>
 <p:sld xmlns:a="http://schemas.openxmlformats.org/drawingml/2006/main" xmlns:p="http://schemas.openxmlformats.org/presentationml/2006/main" xmlns:r="http://schemas.openxmlformats.org/officeDocument/2006/relationships">
   <p:cSld>
     <p:spTree>
@@ -9617,7 +10263,7 @@
                 </a:solidFill>
                 <a:latin typeface="Calibri"/>
               </a:rPr>
-              <a:t>17</a:t>
+              <a:t>18</a:t>
             </a:r>
           </a:p>
         </p:txBody>

</xml_diff>

<commit_message>
Apply adversarial-verification fixes across the revised IPO documents
Verification workflow (4 agents) findings applied: pre-revenue framed
as DD-verified pending Form 1-K/1-SA confirmation wherever load-bearing;
~$0-2M labelled as assessed (not verified) value; $500K note terms
unverified; Route C per-share harmonized to $98-167; $11.4M relabelled
as JV-plan figure; Sidney Tam FA/Third-Director designations marked for
confirmation; briefing/deck as-pitched passages given inline SUPERSEDED
or RESOLVED markers (Eyesel data machinery closed out, gate-zero list
updated, cap-table scenarios marked, entity-name-chain footnote);
CN one-pager legacy-retention 20-25% corrected to verified-value basis,
GLP-1 synergy made conditional, DPW licence made prospective.

Co-Authored-By: Claude Fable 5 <noreply@anthropic.com>
Claude-Session: https://claude.ai/code/session_01AQEsBRx3YjneicK8t6qK39
</commit_message>
<xml_diff>
--- a/synexo/GenApep_Executive_Presentation.pptx
+++ b/synexo/GenApep_Executive_Presentation.pptx
@@ -4151,7 +4151,7 @@
                             <a:srgbClr val="1B3355"/>
                           </a:solidFill>
                         </a:rPr>
-                        <a:t>Filing status unverified</a:t>
+                        <a:t>Filing status — now confirmed Reg A+</a:t>
                       </a:r>
                     </a:p>
                   </a:txBody>
@@ -4173,7 +4173,7 @@
                             <a:srgbClr val="1B3355"/>
                           </a:solidFill>
                         </a:rPr>
-                        <a:t>No identifiable EDGAR record surfaced by name search; a Reg-A filing would not make FVH a reporting company</a:t>
+                        <a:t>Form 1-A confirmed by the Sep-2026 DD: not a reporting company</a:t>
                       </a:r>
                     </a:p>
                   </a:txBody>
@@ -4195,7 +4195,7 @@
                             <a:srgbClr val="1B3355"/>
                           </a:solidFill>
                         </a:rPr>
-                        <a:t>Gate zero: CIK + full EDGAR index, counsel confirmation</a:t>
+                        <a:t>Gate zero remains: CIK/EDGAR index to resolve the FirstVital(s)/ProteusDx entity chain</a:t>
                       </a:r>
                     </a:p>
                   </a:txBody>
@@ -6157,7 +6157,7 @@
                 </a:solidFill>
                 <a:latin typeface="Calibri"/>
               </a:rPr>
-              <a:t>FVH's structure is undetermined — set it by value, enter as one block</a:t>
+              <a:t>SEP-2026: structure now known (cap table 02-Sep); method stands, applied to verified ~$0–2M value</a:t>
             </a:r>
           </a:p>
         </p:txBody>
@@ -6369,13 +6369,13 @@
               </a:spcAft>
             </a:pPr>
             <a:r>
-              <a:rPr sz="1500" b="1">
-                <a:solidFill>
-                  <a:srgbClr val="1B3355"/>
-                </a:solidFill>
-                <a:latin typeface="Calibri"/>
-              </a:rPr>
-              <a:t>Illustrative cap table (GenApep $35M mid · 7.5% pool)</a:t>
+              <a:rPr sz="1300" b="1">
+                <a:solidFill>
+                  <a:srgbClr val="C0392B"/>
+                </a:solidFill>
+                <a:latin typeface="Calibri"/>
+              </a:rPr>
+              <a:t>Cap table scenarios — SUPERSEDED, for record (see slide 2): verified FVH ~$0–2M ⇒ FVH ≈5%</a:t>
             </a:r>
           </a:p>
         </p:txBody>
@@ -7209,7 +7209,7 @@
                 </a:solidFill>
                 <a:latin typeface="Calibri"/>
               </a:rPr>
-              <a:t>Fair without Eyesel's numbers — interim assumptions</a:t>
+              <a:t>Eyesel data machinery — RESOLVED Sep-2026</a:t>
             </a:r>
           </a:p>
         </p:txBody>
@@ -7248,7 +7248,7 @@
                 </a:solidFill>
                 <a:latin typeface="Calibri"/>
               </a:rPr>
-              <a:t>Fairness comes from mechanism, not from guessing the missing data</a:t>
+              <a:t>Statutory FY2025 received: $7.47M @₩1,400 — inside the 15% band; the mechanisms below worked as designed</a:t>
             </a:r>
           </a:p>
         </p:txBody>
@@ -7620,7 +7620,7 @@
                             <a:srgbClr val="1B3355"/>
                           </a:solidFill>
                         </a:rPr>
-                        <a:t>mirrors WBI's certified actual</a:t>
+                        <a:t>planning assumption (WBI margins unverified)</a:t>
                       </a:r>
                     </a:p>
                   </a:txBody>
@@ -8404,7 +8404,7 @@
                 </a:solidFill>
                 <a:latin typeface="Calibri"/>
               </a:rPr>
-              <a:t>Route B (FVH $10M)</a:t>
+              <a:t>Route B as pitched — SUPERSEDED</a:t>
             </a:r>
           </a:p>
           <a:p>
@@ -8428,7 +8428,7 @@
                 </a:solidFill>
                 <a:latin typeface="Calibri"/>
               </a:rPr>
-              <a:t>of the LISTED company · $28–35M if market values group at $80–100M</a:t>
+              <a:t>at the unsupportable FVH-$10M scenario; combined co is NOT listed (Reg A+ only) — see slide 2</a:t>
             </a:r>
           </a:p>
         </p:txBody>
@@ -8619,7 +8619,7 @@
                 <a:latin typeface="Calibri"/>
               </a:rPr>
               <a:t>• MM Studio — WBI's growth engine: $2.9M → $36.3M by 2030, the plan's biggest swing factor.
-• WBI core exports: $4.69M in 2026, +20%/yr, NTS-certified FY2025 base.
+• WBI core exports PLAN: $4.69M in 2026 (+37% vs NTS-certified FY2025 actual ~$3.4M), +20%/yr after.
 • Technology upside (AI.pep, DPW licence) accrues inside GenApep — you participate via the block.</a:t>
             </a:r>
           </a:p>
@@ -9352,7 +9352,7 @@
                 </a:solidFill>
                 <a:latin typeface="Calibri"/>
               </a:rPr>
-              <a:t>ANSWERED (Sep-2026): No. Verified record — pre-revenue, $500K lifetime capital, no reporting status, contingent exposures — supports ~$0–2M, possibly less after the senior $500K note. Every dollar conceded above verified value is a transfer from GenApep shareholders; a clean new US topco costs under $100K.</a:t>
+              <a:t>ANSWERED (Sep-2026): No. The record — pre-revenue per DD (Form 1-K confirmation pending), $500K lifetime capital, no reporting status — supports an assessed ~$0–2M, possibly less after the $500K convertible note (terms unverified). Every dollar conceded above verified value is a transfer from GenApep shareholders; a clean new US topco costs under $100K.</a:t>
             </a:r>
           </a:p>
         </p:txBody>
@@ -10342,7 +10342,7 @@
                             <a:srgbClr val="1B3355"/>
                           </a:solidFill>
                         </a:rPr>
-                        <a:t>Eyesel updated financial report + principal confirmation</a:t>
+                        <a:t>Eyesel FY2025 statutory accounts RECEIVED/verified; principal confirmation (Park vs Kim) in writing</a:t>
                       </a:r>
                     </a:p>
                   </a:txBody>
@@ -11422,7 +11422,7 @@
                 </a:solidFill>
                 <a:latin typeface="Calibri"/>
               </a:rPr>
-              <a:t>Eyesel: updated financials + principal confirmation within 30 days.</a:t>
+              <a:t>Eyesel: financials DELIVERED &amp; verified; principal confirmation (Park vs Kim) within 30 days.</a:t>
             </a:r>
           </a:p>
         </p:txBody>
@@ -12178,7 +12178,7 @@
                             <a:srgbClr val="1B3355"/>
                           </a:solidFill>
                         </a:rPr>
-                        <a:t>RPM services abandoned in the 2024 pivot; pre-revenue; proforma = unvalidated plan</a:t>
+                        <a:t>RPM services abandoned in the 2024 pivot; pre-revenue per DD (1-K pending); proforma = unvalidated plan</a:t>
                       </a:r>
                     </a:p>
                   </a:txBody>
@@ -12246,7 +12246,7 @@
                             <a:srgbClr val="1B3355"/>
                           </a:solidFill>
                         </a:rPr>
-                        <a:t>Lifetime capital $500K (one note); 94.63% one holder; supportable value ~$0–2M</a:t>
+                        <a:t>$75M = Reg A+ Tier 2 regulatory max (offering target $20.74M); capital $500K; 94.63% one holder; assessed value ~$0–2M</a:t>
                       </a:r>
                     </a:p>
                   </a:txBody>
@@ -12519,13 +12519,13 @@
           <a:p>
             <a:pPr algn="ctr"/>
             <a:r>
-              <a:rPr sz="1250" b="0">
+              <a:rPr sz="1200" b="0">
                 <a:solidFill>
                   <a:srgbClr val="5A5A5A"/>
                 </a:solidFill>
                 <a:latin typeface="Calibri"/>
               </a:rPr>
-              <a:t>Governing document: GenApep IPO Plan v2. FirstVitals content on later slides is retained for record.</a:t>
+              <a:t>Governing document: GenApep IPO Plan v2. Evidence is in the name ProteusDx/FirstVitals — identity with “First Vital” to be confirmed at gate zero. Later as-pitched slides retained for record.</a:t>
             </a:r>
           </a:p>
         </p:txBody>
@@ -12803,7 +12803,7 @@
                 </a:solidFill>
                 <a:latin typeface="Calibri"/>
               </a:rPr>
-              <a:t>●  Two new elements have arrived since: First Vital (a US company with a stated SEC filing record and a GLP-1 care programme) proposes to be the listing vehicle, and DPW (under the listed Richards Group) is reviewing a licence to GenApep's technology.</a:t>
+              <a:t>●  Two new elements have arrived since: First Vital (a US company with a stated SEC filing record and a CLAIMED GLP-1 care programme — both examined on the next slide) proposes to be the listing vehicle, and DPW (under the listed Richards Group) is reviewing a licence to GenApep's technology.</a:t>
             </a:r>
           </a:p>
           <a:p>
@@ -13265,7 +13265,7 @@
                 <a:latin typeface="Calibri"/>
               </a:rPr>
               <a:t>Route A (default): GenApep's own US offering — SEC confidential draft by end-2027, listing 2028.
-Route B (option): combine with First Vital, a company with an existing SEC record — only through the machinery in Addendum A.</a:t>
+Route B (option): combine with First Vital — claimed SEC record now verified as Reg A+ 1-A only (see slide 2); any step only through Addendum A machinery.</a:t>
             </a:r>
           </a:p>
         </p:txBody>
@@ -14444,7 +14444,7 @@
                 </a:solidFill>
                 <a:latin typeface="Calibri"/>
               </a:rPr>
-              <a:t>MM Studio ramp $2.9M → $36.3M is the swing factor (WBI-side). Eyesel base $8.0M placeholder +10%/yr — updated financials due within 30 days and the 51:49 rests on them.</a:t>
+              <a:t>MM Studio ramp $2.9M → $36.3M is the swing factor (WBI-side). Eyesel base VERIFIED Sep-2026: statutory FY2025 ₩10.46B (~$7.47M @1,400), inside the 15% band — 51:49 holds.</a:t>
             </a:r>
           </a:p>
         </p:txBody>

</xml_diff>